<commit_message>
ICRNNA against four published architectures on RML2016.10a: first overall, top four within 1.25 points
Colab task literature_2016: VT-CNN2, LSTM2, MCLDNN and PET-CGDNN trained by
train_backbone.py --arch under ICRNNA's protocol (11 classes, same frames,
split and 3 seeds, ceiling 150, patience 20); all converged.

Overall / >= 10 dB, mean of 3 seeds:
  ICRNNA     62.23 / 91.48
  LSTM2      61.44 / 91.54
  MCLDNN     61.41 / 91.06
  PET-CGDNN  60.98 / 90.64
  VT-CNN2    56.07 / 81.96

ICRNNA's edge is between -6 and -2 dB; above 10 dB the top four plateau
near 91%. literature_2016.md, figure 38, a comparison slide in the simple
deck (now 14 slides).

Co-Authored-By: Claude Opus 5.5 <noreply@anthropic.com>
Claude-Session: https://claude.ai/code/session_01UiTC1BeuJK5BZLbarMcqjw
</commit_message>
<xml_diff>
--- a/deck/moshe_2016_simple.pptx
+++ b/deck/moshe_2016_simple.pptx
@@ -18,9 +18,10 @@
     <p:sldId id="266" r:id="rId12"/>
     <p:sldId id="267" r:id="rId13"/>
     <p:sldId id="268" r:id="rId14"/>
+    <p:sldId id="269" r:id="rId15"/>
   </p:sldIdLst>
   <p:notesMasterIdLst>
-    <p:notesMasterId r:id="rId15"/>
+    <p:notesMasterId r:id="rId16"/>
   </p:notesMasterIdLst>
   <p:sldSz cx="12192000" cy="6858000"/>
   <p:notesSz cx="6858000" cy="12192000"/>
@@ -2080,7 +2081,7 @@
           <a:p>
             <a:r>
               <a:rPr lang="en-US" dirty="0"/>
-              <a:t>To sum up. BPSK and QPSK are essentially solved; the mistakes are QAM16 against QAM64. Those mistakes come from having only 16 symbols, not from noise: with 8 or 4 symbols they grow 2.7 and 4.3 times. And 10 dB in this dataset is a setting, not a measurement. Next, I want to switch off the carrier offset, the fading and the echoes one at a time and see which one the QAM mistakes belong to. Thank you.</a:t>
+              <a:t>Is ICRNNA a good choice? I took four well-known published models, from 2016 to 2021, rewrote each one from its authors' benchmark code, and trained all of them exactly like ICRNNA: same data, same split, same three repeats. This time on all eleven types. ICRNNA is first overall, 62.2 percent, but the best four are within about one point of each other. Where ICRNNA gains is between minus 6 and minus 2 dB. Above 10 dB all four stop at about 91 percent, so that limit comes from the data, mostly WBFM and the QAM pair, not from the model. The oldest model, the 2016 CNN, stays about ten points lower up there.</a:t>
             </a:r>
             <a:endParaRPr lang="en-US" dirty="0"/>
           </a:p>
@@ -2104,6 +2105,94 @@
             <a:fld id="{F7021451-1387-4CA6-816F-3879F97B5CBC}" type="slidenum">
               <a:rPr lang="en-US"/>
               <a:t>13</a:t>
+            </a:fld>
+            <a:endParaRPr lang="en-US"/>
+          </a:p>
+        </p:txBody>
+      </p:sp>
+    </p:spTree>
+    <p:extLst>
+      <p:ext uri="{BB962C8B-B14F-4D97-AF65-F5344CB8AC3E}">
+        <p14:creationId xmlns:p14="http://schemas.microsoft.com/office/powerpoint/2010/main" val="1024086991"/>
+      </p:ext>
+    </p:extLst>
+  </p:cSld>
+  <p:clrMapOvr>
+    <a:masterClrMapping/>
+  </p:clrMapOvr>
+</p:notes>
+</file>
+
+<file path=ppt/notesSlides/notesSlide14.xml><?xml version="1.0" encoding="utf-8"?>
+<p:notes xmlns:a="http://schemas.openxmlformats.org/drawingml/2006/main" xmlns:r="http://schemas.openxmlformats.org/officeDocument/2006/relationships" xmlns:p="http://schemas.openxmlformats.org/presentationml/2006/main">
+  <p:cSld>
+    <p:spTree>
+      <p:nvGrpSpPr>
+        <p:cNvPr id="1" name=""/>
+        <p:cNvGrpSpPr/>
+        <p:nvPr/>
+      </p:nvGrpSpPr>
+      <p:grpSpPr>
+        <a:xfrm>
+          <a:off x="0" y="0"/>
+          <a:ext cx="0" cy="0"/>
+          <a:chOff x="0" y="0"/>
+          <a:chExt cx="0" cy="0"/>
+        </a:xfrm>
+      </p:grpSpPr>
+      <p:sp>
+        <p:nvSpPr>
+          <p:cNvPr id="2" name="Slide Image Placeholder 1"/>
+          <p:cNvSpPr>
+            <a:spLocks noGrp="1" noRot="1" noChangeAspect="1"/>
+          </p:cNvSpPr>
+          <p:nvPr>
+            <p:ph type="sldImg"/>
+          </p:nvPr>
+        </p:nvSpPr>
+        <p:spPr/>
+      </p:sp>
+      <p:sp>
+        <p:nvSpPr>
+          <p:cNvPr id="3" name="Notes Placeholder 2"/>
+          <p:cNvSpPr>
+            <a:spLocks noGrp="1"/>
+          </p:cNvSpPr>
+          <p:nvPr>
+            <p:ph type="body" idx="1"/>
+          </p:nvPr>
+        </p:nvSpPr>
+        <p:spPr/>
+        <p:txBody>
+          <a:bodyPr/>
+          <a:lstStyle/>
+          <a:p>
+            <a:r>
+              <a:rPr lang="en-US" dirty="0"/>
+              <a:t>To sum up. BPSK and QPSK are essentially solved; the mistakes are QAM16 against QAM64. Those mistakes come from having only 16 symbols, not from noise: with 8 or 4 symbols they grow 2.7 and 4.3 times. And 10 dB in this dataset is a setting, not a measurement. Next, I want to switch off the carrier offset, the fading and the echoes one at a time and see which one the QAM mistakes belong to. Thank you.</a:t>
+            </a:r>
+            <a:endParaRPr lang="en-US" dirty="0"/>
+          </a:p>
+        </p:txBody>
+      </p:sp>
+      <p:sp>
+        <p:nvSpPr>
+          <p:cNvPr id="4" name="Slide Number Placeholder 3"/>
+          <p:cNvSpPr>
+            <a:spLocks noGrp="1"/>
+          </p:cNvSpPr>
+          <p:nvPr>
+            <p:ph type="sldNum" sz="quarter" idx="10"/>
+          </p:nvPr>
+        </p:nvSpPr>
+        <p:spPr/>
+        <p:txBody>
+          <a:bodyPr/>
+          <a:lstStyle/>
+          <a:p>
+            <a:fld id="{F7021451-1387-4CA6-816F-3879F97B5CBC}" type="slidenum">
+              <a:rPr lang="en-US"/>
+              <a:t>14</a:t>
             </a:fld>
             <a:endParaRPr lang="en-US"/>
           </a:p>
@@ -5479,6 +5568,2379 @@
 <file path=ppt/slides/slide13.xml><?xml version="1.0" encoding="utf-8"?>
 <p:sld xmlns:a="http://schemas.openxmlformats.org/drawingml/2006/main" xmlns:r="http://schemas.openxmlformats.org/officeDocument/2006/relationships" xmlns:p="http://schemas.openxmlformats.org/presentationml/2006/main">
   <p:cSld name="Slide 13">
+    <p:spTree>
+      <p:nvGrpSpPr>
+        <p:cNvPr id="1" name=""/>
+        <p:cNvGrpSpPr/>
+        <p:nvPr/>
+      </p:nvGrpSpPr>
+      <p:grpSpPr>
+        <a:xfrm>
+          <a:off x="0" y="0"/>
+          <a:ext cx="0" cy="0"/>
+          <a:chOff x="0" y="0"/>
+          <a:chExt cx="0" cy="0"/>
+        </a:xfrm>
+      </p:grpSpPr>
+      <p:sp>
+        <p:nvSpPr>
+          <p:cNvPr id="2" name="Text 0"/>
+          <p:cNvSpPr txBox="1"/>
+          <p:nvPr/>
+        </p:nvSpPr>
+        <p:spPr>
+          <a:xfrm>
+            <a:off x="548640" y="384048"/>
+            <a:ext cx="7315200" cy="274320"/>
+          </a:xfrm>
+          <a:prstGeom prst="rect">
+            <a:avLst/>
+          </a:prstGeom>
+          <a:noFill/>
+          <a:ln/>
+        </p:spPr>
+        <p:txBody>
+          <a:bodyPr wrap="square" lIns="0" tIns="0" rIns="0" bIns="0" rtlCol="0" anchor="t"/>
+          <a:lstStyle/>
+          <a:p>
+            <a:pPr indent="0" marL="0">
+              <a:buNone/>
+            </a:pPr>
+            <a:r>
+              <a:rPr lang="en-US" sz="1100" b="1" spc="300" kern="0" dirty="0">
+                <a:solidFill>
+                  <a:srgbClr val="F08A24"/>
+                </a:solidFill>
+                <a:latin typeface="Calibri" pitchFamily="34" charset="0"/>
+                <a:ea typeface="Calibri" pitchFamily="34" charset="-122"/>
+                <a:cs typeface="Calibri" pitchFamily="34" charset="-120"/>
+              </a:rPr>
+              <a:t>COMPARING ARCHITECTURES</a:t>
+            </a:r>
+            <a:endParaRPr lang="en-US" sz="1100" dirty="0"/>
+          </a:p>
+        </p:txBody>
+      </p:sp>
+      <p:sp>
+        <p:nvSpPr>
+          <p:cNvPr id="3" name="Text 1"/>
+          <p:cNvSpPr txBox="1"/>
+          <p:nvPr/>
+        </p:nvSpPr>
+        <p:spPr>
+          <a:xfrm>
+            <a:off x="548640" y="658368"/>
+            <a:ext cx="11091672" cy="640080"/>
+          </a:xfrm>
+          <a:prstGeom prst="rect">
+            <a:avLst/>
+          </a:prstGeom>
+          <a:noFill/>
+          <a:ln/>
+        </p:spPr>
+        <p:txBody>
+          <a:bodyPr wrap="square" lIns="0" tIns="0" rIns="0" bIns="0" rtlCol="0" anchor="ctr"/>
+          <a:lstStyle/>
+          <a:p>
+            <a:pPr indent="0" marL="0">
+              <a:buNone/>
+            </a:pPr>
+            <a:r>
+              <a:rPr lang="en-US" sz="3000" b="1" dirty="0">
+                <a:solidFill>
+                  <a:srgbClr val="1E293B"/>
+                </a:solidFill>
+                <a:latin typeface="Calibri" pitchFamily="34" charset="0"/>
+                <a:ea typeface="Calibri" pitchFamily="34" charset="-122"/>
+                <a:cs typeface="Calibri" pitchFamily="34" charset="-120"/>
+              </a:rPr>
+              <a:t>How does ICRNNA compare with published models?</a:t>
+            </a:r>
+            <a:endParaRPr lang="en-US" sz="3000" dirty="0"/>
+          </a:p>
+        </p:txBody>
+      </p:sp>
+      <p:sp>
+        <p:nvSpPr>
+          <p:cNvPr id="4" name="Shape 2"/>
+          <p:cNvSpPr/>
+          <p:nvPr/>
+        </p:nvSpPr>
+        <p:spPr>
+          <a:xfrm>
+            <a:off x="7872984" y="347472"/>
+            <a:ext cx="3767328" cy="329184"/>
+          </a:xfrm>
+          <a:prstGeom prst="roundRect">
+            <a:avLst>
+              <a:gd name="adj" fmla="val 33333"/>
+            </a:avLst>
+          </a:prstGeom>
+          <a:solidFill>
+            <a:srgbClr val="EEF2F6"/>
+          </a:solidFill>
+          <a:ln w="12700">
+            <a:solidFill>
+              <a:srgbClr val="EEF2F6"/>
+            </a:solidFill>
+            <a:prstDash val="solid"/>
+          </a:ln>
+        </p:spPr>
+      </p:sp>
+      <p:sp>
+        <p:nvSpPr>
+          <p:cNvPr id="5" name="Text 3"/>
+          <p:cNvSpPr txBox="1"/>
+          <p:nvPr/>
+        </p:nvSpPr>
+        <p:spPr>
+          <a:xfrm>
+            <a:off x="7872984" y="347472"/>
+            <a:ext cx="3767328" cy="329184"/>
+          </a:xfrm>
+          <a:prstGeom prst="rect">
+            <a:avLst/>
+          </a:prstGeom>
+          <a:noFill/>
+          <a:ln/>
+        </p:spPr>
+        <p:txBody>
+          <a:bodyPr wrap="square" lIns="0" tIns="0" rIns="0" bIns="0" rtlCol="0" anchor="ctr"/>
+          <a:lstStyle/>
+          <a:p>
+            <a:pPr algn="ctr" indent="0" marL="0">
+              <a:buNone/>
+            </a:pPr>
+            <a:r>
+              <a:rPr lang="en-US" sz="1100" dirty="0">
+                <a:solidFill>
+                  <a:srgbClr val="1E293B"/>
+                </a:solidFill>
+                <a:latin typeface="Consolas" pitchFamily="34" charset="0"/>
+                <a:ea typeface="Consolas" pitchFamily="34" charset="-122"/>
+                <a:cs typeface="Consolas" pitchFamily="34" charset="-120"/>
+              </a:rPr>
+              <a:t>train_backbone.py --arch MCLDNN</a:t>
+            </a:r>
+            <a:endParaRPr lang="en-US" sz="1100" dirty="0"/>
+          </a:p>
+        </p:txBody>
+      </p:sp>
+      <p:sp>
+        <p:nvSpPr>
+          <p:cNvPr id="6" name="Text 4"/>
+          <p:cNvSpPr txBox="1"/>
+          <p:nvPr/>
+        </p:nvSpPr>
+        <p:spPr>
+          <a:xfrm>
+            <a:off x="548640" y="1371600"/>
+            <a:ext cx="11091672" cy="365760"/>
+          </a:xfrm>
+          <a:prstGeom prst="rect">
+            <a:avLst/>
+          </a:prstGeom>
+          <a:noFill/>
+          <a:ln/>
+        </p:spPr>
+        <p:txBody>
+          <a:bodyPr wrap="square" lIns="0" tIns="0" rIns="0" bIns="0" rtlCol="0" anchor="t"/>
+          <a:lstStyle/>
+          <a:p>
+            <a:pPr indent="0" marL="0">
+              <a:buNone/>
+            </a:pPr>
+            <a:r>
+              <a:rPr lang="en-US" sz="1400" dirty="0">
+                <a:solidFill>
+                  <a:srgbClr val="5B6B7F"/>
+                </a:solidFill>
+                <a:latin typeface="Calibri" pitchFamily="34" charset="0"/>
+                <a:ea typeface="Calibri" pitchFamily="34" charset="-122"/>
+                <a:cs typeface="Calibri" pitchFamily="34" charset="-120"/>
+              </a:rPr>
+              <a:t>All 11 types, all noise levels. Same data, same split, same 3 repeats for every model: only the model changes.</a:t>
+            </a:r>
+            <a:endParaRPr lang="en-US" sz="1400" dirty="0"/>
+          </a:p>
+        </p:txBody>
+      </p:sp>
+      <p:graphicFrame>
+        <p:nvGraphicFramePr>
+          <p:cNvPr id="14" name="Table 0"/>
+          <p:cNvGraphicFramePr>
+            <a:graphicFrameLocks noGrp="1"/>
+          </p:cNvGraphicFramePr>
+          <p:nvPr>
+            <p:extLst>
+              <p:ext uri="{D42A27DB-BD31-4B8C-83A1-F6EECF244321}">
+                <p14:modId xmlns:p14="http://schemas.microsoft.com/office/powerpoint/2010/main" val="1579011935"/>
+              </p:ext>
+            </p:extLst>
+          </p:nvPr>
+        </p:nvGraphicFramePr>
+        <p:xfrm>
+          <a:off x="548640" y="1874520"/>
+          <a:ext cx="6035040" cy="914400"/>
+        </p:xfrm>
+        <a:graphic>
+          <a:graphicData uri="http://schemas.openxmlformats.org/drawingml/2006/table">
+            <a:tbl>
+              <a:tblPr/>
+              <a:tblGrid>
+                <a:gridCol w="1417320"/>
+                <a:gridCol w="731520"/>
+                <a:gridCol w="1417320"/>
+                <a:gridCol w="1097280"/>
+                <a:gridCol w="1371600"/>
+              </a:tblGrid>
+              <a:tr h="475488">
+                <a:tc>
+                  <a:txBody>
+                    <a:bodyPr/>
+                    <a:lstStyle/>
+                    <a:p>
+                      <a:pPr algn="l" indent="0" marL="0">
+                        <a:buNone/>
+                      </a:pPr>
+                      <a:r>
+                        <a:rPr lang="en-US" sz="1300" b="1" dirty="0">
+                          <a:solidFill>
+                            <a:srgbClr val="1E293B"/>
+                          </a:solidFill>
+                          <a:latin typeface="Calibri" pitchFamily="34" charset="0"/>
+                          <a:ea typeface="Calibri" pitchFamily="34" charset="-122"/>
+                          <a:cs typeface="Calibri" pitchFamily="34" charset="-120"/>
+                        </a:rPr>
+                        <a:t>model</a:t>
+                      </a:r>
+                      <a:endParaRPr lang="en-US" sz="1300" dirty="0">
+                        <a:latin typeface="Calibri" charset="0"/>
+                        <a:ea typeface="Calibri" charset="0"/>
+                        <a:cs typeface="Calibri" charset="0"/>
+                      </a:endParaRPr>
+                    </a:p>
+                  </a:txBody>
+                  <a:tcPr marL="91440" marR="91440" marT="45720" marB="45720" anchor="ctr">
+                    <a:lnL w="6350" cap="flat" cmpd="sng" algn="ctr">
+                      <a:solidFill>
+                        <a:srgbClr val="D5DDE5"/>
+                      </a:solidFill>
+                      <a:prstDash val="solid"/>
+                      <a:round/>
+                      <a:headEnd type="none" w="med" len="med"/>
+                      <a:tailEnd type="none" w="med" len="med"/>
+                    </a:lnL>
+                    <a:lnR w="6350" cap="flat" cmpd="sng" algn="ctr">
+                      <a:solidFill>
+                        <a:srgbClr val="D5DDE5"/>
+                      </a:solidFill>
+                      <a:prstDash val="solid"/>
+                      <a:round/>
+                      <a:headEnd type="none" w="med" len="med"/>
+                      <a:tailEnd type="none" w="med" len="med"/>
+                    </a:lnR>
+                    <a:lnT w="6350" cap="flat" cmpd="sng" algn="ctr">
+                      <a:solidFill>
+                        <a:srgbClr val="D5DDE5"/>
+                      </a:solidFill>
+                      <a:prstDash val="solid"/>
+                      <a:round/>
+                      <a:headEnd type="none" w="med" len="med"/>
+                      <a:tailEnd type="none" w="med" len="med"/>
+                    </a:lnT>
+                    <a:lnB w="6350" cap="flat" cmpd="sng" algn="ctr">
+                      <a:solidFill>
+                        <a:srgbClr val="D5DDE5"/>
+                      </a:solidFill>
+                      <a:prstDash val="solid"/>
+                      <a:round/>
+                      <a:headEnd type="none" w="med" len="med"/>
+                      <a:tailEnd type="none" w="med" len="med"/>
+                    </a:lnB>
+                    <a:solidFill>
+                      <a:srgbClr val="EEF2F6"/>
+                    </a:solidFill>
+                  </a:tcPr>
+                </a:tc>
+                <a:tc>
+                  <a:txBody>
+                    <a:bodyPr/>
+                    <a:lstStyle/>
+                    <a:p>
+                      <a:pPr algn="ctr" indent="0" marL="0">
+                        <a:buNone/>
+                      </a:pPr>
+                      <a:r>
+                        <a:rPr lang="en-US" sz="1300" b="1" dirty="0">
+                          <a:solidFill>
+                            <a:srgbClr val="1E293B"/>
+                          </a:solidFill>
+                          <a:latin typeface="Calibri" pitchFamily="34" charset="0"/>
+                          <a:ea typeface="Calibri" pitchFamily="34" charset="-122"/>
+                          <a:cs typeface="Calibri" pitchFamily="34" charset="-120"/>
+                        </a:rPr>
+                        <a:t>year</a:t>
+                      </a:r>
+                      <a:endParaRPr lang="en-US" sz="1300" dirty="0">
+                        <a:latin typeface="Calibri" charset="0"/>
+                        <a:ea typeface="Calibri" charset="0"/>
+                        <a:cs typeface="Calibri" charset="0"/>
+                      </a:endParaRPr>
+                    </a:p>
+                  </a:txBody>
+                  <a:tcPr marL="91440" marR="91440" marT="45720" marB="45720" anchor="ctr">
+                    <a:lnL w="6350" cap="flat" cmpd="sng" algn="ctr">
+                      <a:solidFill>
+                        <a:srgbClr val="D5DDE5"/>
+                      </a:solidFill>
+                      <a:prstDash val="solid"/>
+                      <a:round/>
+                      <a:headEnd type="none" w="med" len="med"/>
+                      <a:tailEnd type="none" w="med" len="med"/>
+                    </a:lnL>
+                    <a:lnR w="6350" cap="flat" cmpd="sng" algn="ctr">
+                      <a:solidFill>
+                        <a:srgbClr val="D5DDE5"/>
+                      </a:solidFill>
+                      <a:prstDash val="solid"/>
+                      <a:round/>
+                      <a:headEnd type="none" w="med" len="med"/>
+                      <a:tailEnd type="none" w="med" len="med"/>
+                    </a:lnR>
+                    <a:lnT w="6350" cap="flat" cmpd="sng" algn="ctr">
+                      <a:solidFill>
+                        <a:srgbClr val="D5DDE5"/>
+                      </a:solidFill>
+                      <a:prstDash val="solid"/>
+                      <a:round/>
+                      <a:headEnd type="none" w="med" len="med"/>
+                      <a:tailEnd type="none" w="med" len="med"/>
+                    </a:lnT>
+                    <a:lnB w="6350" cap="flat" cmpd="sng" algn="ctr">
+                      <a:solidFill>
+                        <a:srgbClr val="D5DDE5"/>
+                      </a:solidFill>
+                      <a:prstDash val="solid"/>
+                      <a:round/>
+                      <a:headEnd type="none" w="med" len="med"/>
+                      <a:tailEnd type="none" w="med" len="med"/>
+                    </a:lnB>
+                    <a:solidFill>
+                      <a:srgbClr val="EEF2F6"/>
+                    </a:solidFill>
+                  </a:tcPr>
+                </a:tc>
+                <a:tc>
+                  <a:txBody>
+                    <a:bodyPr/>
+                    <a:lstStyle/>
+                    <a:p>
+                      <a:pPr algn="ctr" indent="0" marL="0">
+                        <a:buNone/>
+                      </a:pPr>
+                      <a:r>
+                        <a:rPr lang="en-US" sz="1300" b="1" dirty="0">
+                          <a:solidFill>
+                            <a:srgbClr val="1E293B"/>
+                          </a:solidFill>
+                          <a:latin typeface="Calibri" pitchFamily="34" charset="0"/>
+                          <a:ea typeface="Calibri" pitchFamily="34" charset="-122"/>
+                          <a:cs typeface="Calibri" pitchFamily="34" charset="-120"/>
+                        </a:rPr>
+                        <a:t>numbers learned</a:t>
+                      </a:r>
+                      <a:endParaRPr lang="en-US" sz="1300" dirty="0">
+                        <a:latin typeface="Calibri" charset="0"/>
+                        <a:ea typeface="Calibri" charset="0"/>
+                        <a:cs typeface="Calibri" charset="0"/>
+                      </a:endParaRPr>
+                    </a:p>
+                  </a:txBody>
+                  <a:tcPr marL="91440" marR="91440" marT="45720" marB="45720" anchor="ctr">
+                    <a:lnL w="6350" cap="flat" cmpd="sng" algn="ctr">
+                      <a:solidFill>
+                        <a:srgbClr val="D5DDE5"/>
+                      </a:solidFill>
+                      <a:prstDash val="solid"/>
+                      <a:round/>
+                      <a:headEnd type="none" w="med" len="med"/>
+                      <a:tailEnd type="none" w="med" len="med"/>
+                    </a:lnL>
+                    <a:lnR w="6350" cap="flat" cmpd="sng" algn="ctr">
+                      <a:solidFill>
+                        <a:srgbClr val="D5DDE5"/>
+                      </a:solidFill>
+                      <a:prstDash val="solid"/>
+                      <a:round/>
+                      <a:headEnd type="none" w="med" len="med"/>
+                      <a:tailEnd type="none" w="med" len="med"/>
+                    </a:lnR>
+                    <a:lnT w="6350" cap="flat" cmpd="sng" algn="ctr">
+                      <a:solidFill>
+                        <a:srgbClr val="D5DDE5"/>
+                      </a:solidFill>
+                      <a:prstDash val="solid"/>
+                      <a:round/>
+                      <a:headEnd type="none" w="med" len="med"/>
+                      <a:tailEnd type="none" w="med" len="med"/>
+                    </a:lnT>
+                    <a:lnB w="6350" cap="flat" cmpd="sng" algn="ctr">
+                      <a:solidFill>
+                        <a:srgbClr val="D5DDE5"/>
+                      </a:solidFill>
+                      <a:prstDash val="solid"/>
+                      <a:round/>
+                      <a:headEnd type="none" w="med" len="med"/>
+                      <a:tailEnd type="none" w="med" len="med"/>
+                    </a:lnB>
+                    <a:solidFill>
+                      <a:srgbClr val="EEF2F6"/>
+                    </a:solidFill>
+                  </a:tcPr>
+                </a:tc>
+                <a:tc>
+                  <a:txBody>
+                    <a:bodyPr/>
+                    <a:lstStyle/>
+                    <a:p>
+                      <a:pPr algn="ctr" indent="0" marL="0">
+                        <a:buNone/>
+                      </a:pPr>
+                      <a:r>
+                        <a:rPr lang="en-US" sz="1300" b="1" dirty="0">
+                          <a:solidFill>
+                            <a:srgbClr val="1E293B"/>
+                          </a:solidFill>
+                          <a:latin typeface="Calibri" pitchFamily="34" charset="0"/>
+                          <a:ea typeface="Calibri" pitchFamily="34" charset="-122"/>
+                          <a:cs typeface="Calibri" pitchFamily="34" charset="-120"/>
+                        </a:rPr>
+                        <a:t>overall</a:t>
+                      </a:r>
+                      <a:endParaRPr lang="en-US" sz="1300" dirty="0">
+                        <a:latin typeface="Calibri" charset="0"/>
+                        <a:ea typeface="Calibri" charset="0"/>
+                        <a:cs typeface="Calibri" charset="0"/>
+                      </a:endParaRPr>
+                    </a:p>
+                  </a:txBody>
+                  <a:tcPr marL="91440" marR="91440" marT="45720" marB="45720" anchor="ctr">
+                    <a:lnL w="6350" cap="flat" cmpd="sng" algn="ctr">
+                      <a:solidFill>
+                        <a:srgbClr val="D5DDE5"/>
+                      </a:solidFill>
+                      <a:prstDash val="solid"/>
+                      <a:round/>
+                      <a:headEnd type="none" w="med" len="med"/>
+                      <a:tailEnd type="none" w="med" len="med"/>
+                    </a:lnL>
+                    <a:lnR w="6350" cap="flat" cmpd="sng" algn="ctr">
+                      <a:solidFill>
+                        <a:srgbClr val="D5DDE5"/>
+                      </a:solidFill>
+                      <a:prstDash val="solid"/>
+                      <a:round/>
+                      <a:headEnd type="none" w="med" len="med"/>
+                      <a:tailEnd type="none" w="med" len="med"/>
+                    </a:lnR>
+                    <a:lnT w="6350" cap="flat" cmpd="sng" algn="ctr">
+                      <a:solidFill>
+                        <a:srgbClr val="D5DDE5"/>
+                      </a:solidFill>
+                      <a:prstDash val="solid"/>
+                      <a:round/>
+                      <a:headEnd type="none" w="med" len="med"/>
+                      <a:tailEnd type="none" w="med" len="med"/>
+                    </a:lnT>
+                    <a:lnB w="6350" cap="flat" cmpd="sng" algn="ctr">
+                      <a:solidFill>
+                        <a:srgbClr val="D5DDE5"/>
+                      </a:solidFill>
+                      <a:prstDash val="solid"/>
+                      <a:round/>
+                      <a:headEnd type="none" w="med" len="med"/>
+                      <a:tailEnd type="none" w="med" len="med"/>
+                    </a:lnB>
+                    <a:solidFill>
+                      <a:srgbClr val="EEF2F6"/>
+                    </a:solidFill>
+                  </a:tcPr>
+                </a:tc>
+                <a:tc>
+                  <a:txBody>
+                    <a:bodyPr/>
+                    <a:lstStyle/>
+                    <a:p>
+                      <a:pPr algn="ctr" indent="0" marL="0">
+                        <a:buNone/>
+                      </a:pPr>
+                      <a:r>
+                        <a:rPr lang="en-US" sz="1300" b="1" dirty="0">
+                          <a:solidFill>
+                            <a:srgbClr val="1E293B"/>
+                          </a:solidFill>
+                          <a:latin typeface="Calibri" pitchFamily="34" charset="0"/>
+                          <a:ea typeface="Calibri" pitchFamily="34" charset="-122"/>
+                          <a:cs typeface="Calibri" pitchFamily="34" charset="-120"/>
+                        </a:rPr>
+                        <a:t>at 10 dB and above</a:t>
+                      </a:r>
+                      <a:endParaRPr lang="en-US" sz="1300" dirty="0">
+                        <a:latin typeface="Calibri" charset="0"/>
+                        <a:ea typeface="Calibri" charset="0"/>
+                        <a:cs typeface="Calibri" charset="0"/>
+                      </a:endParaRPr>
+                    </a:p>
+                  </a:txBody>
+                  <a:tcPr marL="91440" marR="91440" marT="45720" marB="45720" anchor="ctr">
+                    <a:lnL w="6350" cap="flat" cmpd="sng" algn="ctr">
+                      <a:solidFill>
+                        <a:srgbClr val="D5DDE5"/>
+                      </a:solidFill>
+                      <a:prstDash val="solid"/>
+                      <a:round/>
+                      <a:headEnd type="none" w="med" len="med"/>
+                      <a:tailEnd type="none" w="med" len="med"/>
+                    </a:lnL>
+                    <a:lnR w="6350" cap="flat" cmpd="sng" algn="ctr">
+                      <a:solidFill>
+                        <a:srgbClr val="D5DDE5"/>
+                      </a:solidFill>
+                      <a:prstDash val="solid"/>
+                      <a:round/>
+                      <a:headEnd type="none" w="med" len="med"/>
+                      <a:tailEnd type="none" w="med" len="med"/>
+                    </a:lnR>
+                    <a:lnT w="6350" cap="flat" cmpd="sng" algn="ctr">
+                      <a:solidFill>
+                        <a:srgbClr val="D5DDE5"/>
+                      </a:solidFill>
+                      <a:prstDash val="solid"/>
+                      <a:round/>
+                      <a:headEnd type="none" w="med" len="med"/>
+                      <a:tailEnd type="none" w="med" len="med"/>
+                    </a:lnT>
+                    <a:lnB w="6350" cap="flat" cmpd="sng" algn="ctr">
+                      <a:solidFill>
+                        <a:srgbClr val="D5DDE5"/>
+                      </a:solidFill>
+                      <a:prstDash val="solid"/>
+                      <a:round/>
+                      <a:headEnd type="none" w="med" len="med"/>
+                      <a:tailEnd type="none" w="med" len="med"/>
+                    </a:lnB>
+                    <a:solidFill>
+                      <a:srgbClr val="EEF2F6"/>
+                    </a:solidFill>
+                  </a:tcPr>
+                </a:tc>
+              </a:tr>
+              <a:tr h="475488">
+                <a:tc>
+                  <a:txBody>
+                    <a:bodyPr/>
+                    <a:lstStyle/>
+                    <a:p>
+                      <a:pPr algn="l" indent="0" marL="0">
+                        <a:buNone/>
+                      </a:pPr>
+                      <a:r>
+                        <a:rPr lang="en-US" sz="1400" b="1" dirty="0">
+                          <a:solidFill>
+                            <a:srgbClr val="F08A24"/>
+                          </a:solidFill>
+                          <a:latin typeface="Calibri" pitchFamily="34" charset="0"/>
+                          <a:ea typeface="Calibri" pitchFamily="34" charset="-122"/>
+                          <a:cs typeface="Calibri" pitchFamily="34" charset="-120"/>
+                        </a:rPr>
+                        <a:t>ICRNNA</a:t>
+                      </a:r>
+                      <a:endParaRPr lang="en-US" sz="1400" dirty="0">
+                        <a:latin typeface="Calibri" charset="0"/>
+                        <a:ea typeface="Calibri" charset="0"/>
+                        <a:cs typeface="Calibri" charset="0"/>
+                      </a:endParaRPr>
+                    </a:p>
+                  </a:txBody>
+                  <a:tcPr marL="91440" marR="91440" marT="45720" marB="45720" anchor="ctr">
+                    <a:lnL w="6350" cap="flat" cmpd="sng" algn="ctr">
+                      <a:solidFill>
+                        <a:srgbClr val="D5DDE5"/>
+                      </a:solidFill>
+                      <a:prstDash val="solid"/>
+                      <a:round/>
+                      <a:headEnd type="none" w="med" len="med"/>
+                      <a:tailEnd type="none" w="med" len="med"/>
+                    </a:lnL>
+                    <a:lnR w="6350" cap="flat" cmpd="sng" algn="ctr">
+                      <a:solidFill>
+                        <a:srgbClr val="D5DDE5"/>
+                      </a:solidFill>
+                      <a:prstDash val="solid"/>
+                      <a:round/>
+                      <a:headEnd type="none" w="med" len="med"/>
+                      <a:tailEnd type="none" w="med" len="med"/>
+                    </a:lnR>
+                    <a:lnT w="6350" cap="flat" cmpd="sng" algn="ctr">
+                      <a:solidFill>
+                        <a:srgbClr val="D5DDE5"/>
+                      </a:solidFill>
+                      <a:prstDash val="solid"/>
+                      <a:round/>
+                      <a:headEnd type="none" w="med" len="med"/>
+                      <a:tailEnd type="none" w="med" len="med"/>
+                    </a:lnT>
+                    <a:lnB w="6350" cap="flat" cmpd="sng" algn="ctr">
+                      <a:solidFill>
+                        <a:srgbClr val="D5DDE5"/>
+                      </a:solidFill>
+                      <a:prstDash val="solid"/>
+                      <a:round/>
+                      <a:headEnd type="none" w="med" len="med"/>
+                      <a:tailEnd type="none" w="med" len="med"/>
+                    </a:lnB>
+                  </a:tcPr>
+                </a:tc>
+                <a:tc>
+                  <a:txBody>
+                    <a:bodyPr/>
+                    <a:lstStyle/>
+                    <a:p>
+                      <a:pPr algn="ctr" indent="0" marL="0">
+                        <a:buNone/>
+                      </a:pPr>
+                      <a:r>
+                        <a:rPr lang="en-US" sz="1400" b="1" dirty="0">
+                          <a:solidFill>
+                            <a:srgbClr val="F08A24"/>
+                          </a:solidFill>
+                          <a:latin typeface="Calibri" pitchFamily="34" charset="0"/>
+                          <a:ea typeface="Calibri" pitchFamily="34" charset="-122"/>
+                          <a:cs typeface="Calibri" pitchFamily="34" charset="-120"/>
+                        </a:rPr>
+                        <a:t>2025</a:t>
+                      </a:r>
+                      <a:endParaRPr lang="en-US" sz="1400" dirty="0">
+                        <a:latin typeface="Calibri" charset="0"/>
+                        <a:ea typeface="Calibri" charset="0"/>
+                        <a:cs typeface="Calibri" charset="0"/>
+                      </a:endParaRPr>
+                    </a:p>
+                  </a:txBody>
+                  <a:tcPr marL="91440" marR="91440" marT="45720" marB="45720" anchor="ctr">
+                    <a:lnL w="6350" cap="flat" cmpd="sng" algn="ctr">
+                      <a:solidFill>
+                        <a:srgbClr val="D5DDE5"/>
+                      </a:solidFill>
+                      <a:prstDash val="solid"/>
+                      <a:round/>
+                      <a:headEnd type="none" w="med" len="med"/>
+                      <a:tailEnd type="none" w="med" len="med"/>
+                    </a:lnL>
+                    <a:lnR w="6350" cap="flat" cmpd="sng" algn="ctr">
+                      <a:solidFill>
+                        <a:srgbClr val="D5DDE5"/>
+                      </a:solidFill>
+                      <a:prstDash val="solid"/>
+                      <a:round/>
+                      <a:headEnd type="none" w="med" len="med"/>
+                      <a:tailEnd type="none" w="med" len="med"/>
+                    </a:lnR>
+                    <a:lnT w="6350" cap="flat" cmpd="sng" algn="ctr">
+                      <a:solidFill>
+                        <a:srgbClr val="D5DDE5"/>
+                      </a:solidFill>
+                      <a:prstDash val="solid"/>
+                      <a:round/>
+                      <a:headEnd type="none" w="med" len="med"/>
+                      <a:tailEnd type="none" w="med" len="med"/>
+                    </a:lnT>
+                    <a:lnB w="6350" cap="flat" cmpd="sng" algn="ctr">
+                      <a:solidFill>
+                        <a:srgbClr val="D5DDE5"/>
+                      </a:solidFill>
+                      <a:prstDash val="solid"/>
+                      <a:round/>
+                      <a:headEnd type="none" w="med" len="med"/>
+                      <a:tailEnd type="none" w="med" len="med"/>
+                    </a:lnB>
+                  </a:tcPr>
+                </a:tc>
+                <a:tc>
+                  <a:txBody>
+                    <a:bodyPr/>
+                    <a:lstStyle/>
+                    <a:p>
+                      <a:pPr algn="ctr" indent="0" marL="0">
+                        <a:buNone/>
+                      </a:pPr>
+                      <a:r>
+                        <a:rPr lang="en-US" sz="1400" b="1" dirty="0">
+                          <a:solidFill>
+                            <a:srgbClr val="F08A24"/>
+                          </a:solidFill>
+                          <a:latin typeface="Calibri" pitchFamily="34" charset="0"/>
+                          <a:ea typeface="Calibri" pitchFamily="34" charset="-122"/>
+                          <a:cs typeface="Calibri" pitchFamily="34" charset="-120"/>
+                        </a:rPr>
+                        <a:t>786,379</a:t>
+                      </a:r>
+                      <a:endParaRPr lang="en-US" sz="1400" dirty="0">
+                        <a:latin typeface="Calibri" charset="0"/>
+                        <a:ea typeface="Calibri" charset="0"/>
+                        <a:cs typeface="Calibri" charset="0"/>
+                      </a:endParaRPr>
+                    </a:p>
+                  </a:txBody>
+                  <a:tcPr marL="91440" marR="91440" marT="45720" marB="45720" anchor="ctr">
+                    <a:lnL w="6350" cap="flat" cmpd="sng" algn="ctr">
+                      <a:solidFill>
+                        <a:srgbClr val="D5DDE5"/>
+                      </a:solidFill>
+                      <a:prstDash val="solid"/>
+                      <a:round/>
+                      <a:headEnd type="none" w="med" len="med"/>
+                      <a:tailEnd type="none" w="med" len="med"/>
+                    </a:lnL>
+                    <a:lnR w="6350" cap="flat" cmpd="sng" algn="ctr">
+                      <a:solidFill>
+                        <a:srgbClr val="D5DDE5"/>
+                      </a:solidFill>
+                      <a:prstDash val="solid"/>
+                      <a:round/>
+                      <a:headEnd type="none" w="med" len="med"/>
+                      <a:tailEnd type="none" w="med" len="med"/>
+                    </a:lnR>
+                    <a:lnT w="6350" cap="flat" cmpd="sng" algn="ctr">
+                      <a:solidFill>
+                        <a:srgbClr val="D5DDE5"/>
+                      </a:solidFill>
+                      <a:prstDash val="solid"/>
+                      <a:round/>
+                      <a:headEnd type="none" w="med" len="med"/>
+                      <a:tailEnd type="none" w="med" len="med"/>
+                    </a:lnT>
+                    <a:lnB w="6350" cap="flat" cmpd="sng" algn="ctr">
+                      <a:solidFill>
+                        <a:srgbClr val="D5DDE5"/>
+                      </a:solidFill>
+                      <a:prstDash val="solid"/>
+                      <a:round/>
+                      <a:headEnd type="none" w="med" len="med"/>
+                      <a:tailEnd type="none" w="med" len="med"/>
+                    </a:lnB>
+                  </a:tcPr>
+                </a:tc>
+                <a:tc>
+                  <a:txBody>
+                    <a:bodyPr/>
+                    <a:lstStyle/>
+                    <a:p>
+                      <a:pPr algn="ctr" indent="0" marL="0">
+                        <a:buNone/>
+                      </a:pPr>
+                      <a:r>
+                        <a:rPr lang="en-US" sz="1400" b="1" dirty="0">
+                          <a:solidFill>
+                            <a:srgbClr val="F08A24"/>
+                          </a:solidFill>
+                          <a:latin typeface="Calibri" pitchFamily="34" charset="0"/>
+                          <a:ea typeface="Calibri" pitchFamily="34" charset="-122"/>
+                          <a:cs typeface="Calibri" pitchFamily="34" charset="-120"/>
+                        </a:rPr>
+                        <a:t>62.2%</a:t>
+                      </a:r>
+                      <a:endParaRPr lang="en-US" sz="1400" dirty="0">
+                        <a:latin typeface="Calibri" charset="0"/>
+                        <a:ea typeface="Calibri" charset="0"/>
+                        <a:cs typeface="Calibri" charset="0"/>
+                      </a:endParaRPr>
+                    </a:p>
+                  </a:txBody>
+                  <a:tcPr marL="91440" marR="91440" marT="45720" marB="45720" anchor="ctr">
+                    <a:lnL w="6350" cap="flat" cmpd="sng" algn="ctr">
+                      <a:solidFill>
+                        <a:srgbClr val="D5DDE5"/>
+                      </a:solidFill>
+                      <a:prstDash val="solid"/>
+                      <a:round/>
+                      <a:headEnd type="none" w="med" len="med"/>
+                      <a:tailEnd type="none" w="med" len="med"/>
+                    </a:lnL>
+                    <a:lnR w="6350" cap="flat" cmpd="sng" algn="ctr">
+                      <a:solidFill>
+                        <a:srgbClr val="D5DDE5"/>
+                      </a:solidFill>
+                      <a:prstDash val="solid"/>
+                      <a:round/>
+                      <a:headEnd type="none" w="med" len="med"/>
+                      <a:tailEnd type="none" w="med" len="med"/>
+                    </a:lnR>
+                    <a:lnT w="6350" cap="flat" cmpd="sng" algn="ctr">
+                      <a:solidFill>
+                        <a:srgbClr val="D5DDE5"/>
+                      </a:solidFill>
+                      <a:prstDash val="solid"/>
+                      <a:round/>
+                      <a:headEnd type="none" w="med" len="med"/>
+                      <a:tailEnd type="none" w="med" len="med"/>
+                    </a:lnT>
+                    <a:lnB w="6350" cap="flat" cmpd="sng" algn="ctr">
+                      <a:solidFill>
+                        <a:srgbClr val="D5DDE5"/>
+                      </a:solidFill>
+                      <a:prstDash val="solid"/>
+                      <a:round/>
+                      <a:headEnd type="none" w="med" len="med"/>
+                      <a:tailEnd type="none" w="med" len="med"/>
+                    </a:lnB>
+                  </a:tcPr>
+                </a:tc>
+                <a:tc>
+                  <a:txBody>
+                    <a:bodyPr/>
+                    <a:lstStyle/>
+                    <a:p>
+                      <a:pPr algn="ctr" indent="0" marL="0">
+                        <a:buNone/>
+                      </a:pPr>
+                      <a:r>
+                        <a:rPr lang="en-US" sz="1400" b="1" dirty="0">
+                          <a:solidFill>
+                            <a:srgbClr val="F08A24"/>
+                          </a:solidFill>
+                          <a:latin typeface="Calibri" pitchFamily="34" charset="0"/>
+                          <a:ea typeface="Calibri" pitchFamily="34" charset="-122"/>
+                          <a:cs typeface="Calibri" pitchFamily="34" charset="-120"/>
+                        </a:rPr>
+                        <a:t>91.5%</a:t>
+                      </a:r>
+                      <a:endParaRPr lang="en-US" sz="1400" dirty="0">
+                        <a:latin typeface="Calibri" charset="0"/>
+                        <a:ea typeface="Calibri" charset="0"/>
+                        <a:cs typeface="Calibri" charset="0"/>
+                      </a:endParaRPr>
+                    </a:p>
+                  </a:txBody>
+                  <a:tcPr marL="91440" marR="91440" marT="45720" marB="45720" anchor="ctr">
+                    <a:lnL w="6350" cap="flat" cmpd="sng" algn="ctr">
+                      <a:solidFill>
+                        <a:srgbClr val="D5DDE5"/>
+                      </a:solidFill>
+                      <a:prstDash val="solid"/>
+                      <a:round/>
+                      <a:headEnd type="none" w="med" len="med"/>
+                      <a:tailEnd type="none" w="med" len="med"/>
+                    </a:lnL>
+                    <a:lnR w="6350" cap="flat" cmpd="sng" algn="ctr">
+                      <a:solidFill>
+                        <a:srgbClr val="D5DDE5"/>
+                      </a:solidFill>
+                      <a:prstDash val="solid"/>
+                      <a:round/>
+                      <a:headEnd type="none" w="med" len="med"/>
+                      <a:tailEnd type="none" w="med" len="med"/>
+                    </a:lnR>
+                    <a:lnT w="6350" cap="flat" cmpd="sng" algn="ctr">
+                      <a:solidFill>
+                        <a:srgbClr val="D5DDE5"/>
+                      </a:solidFill>
+                      <a:prstDash val="solid"/>
+                      <a:round/>
+                      <a:headEnd type="none" w="med" len="med"/>
+                      <a:tailEnd type="none" w="med" len="med"/>
+                    </a:lnT>
+                    <a:lnB w="6350" cap="flat" cmpd="sng" algn="ctr">
+                      <a:solidFill>
+                        <a:srgbClr val="D5DDE5"/>
+                      </a:solidFill>
+                      <a:prstDash val="solid"/>
+                      <a:round/>
+                      <a:headEnd type="none" w="med" len="med"/>
+                      <a:tailEnd type="none" w="med" len="med"/>
+                    </a:lnB>
+                  </a:tcPr>
+                </a:tc>
+              </a:tr>
+              <a:tr h="475488">
+                <a:tc>
+                  <a:txBody>
+                    <a:bodyPr/>
+                    <a:lstStyle/>
+                    <a:p>
+                      <a:pPr algn="l" indent="0" marL="0">
+                        <a:buNone/>
+                      </a:pPr>
+                      <a:r>
+                        <a:rPr lang="en-US" sz="1400" dirty="0">
+                          <a:solidFill>
+                            <a:srgbClr val="1E293B"/>
+                          </a:solidFill>
+                          <a:latin typeface="Calibri" pitchFamily="34" charset="0"/>
+                          <a:ea typeface="Calibri" pitchFamily="34" charset="-122"/>
+                          <a:cs typeface="Calibri" pitchFamily="34" charset="-120"/>
+                        </a:rPr>
+                        <a:t>LSTM2</a:t>
+                      </a:r>
+                      <a:endParaRPr lang="en-US" sz="1400" dirty="0">
+                        <a:latin typeface="Calibri" charset="0"/>
+                        <a:ea typeface="Calibri" charset="0"/>
+                        <a:cs typeface="Calibri" charset="0"/>
+                      </a:endParaRPr>
+                    </a:p>
+                  </a:txBody>
+                  <a:tcPr marL="91440" marR="91440" marT="45720" marB="45720" anchor="ctr">
+                    <a:lnL w="6350" cap="flat" cmpd="sng" algn="ctr">
+                      <a:solidFill>
+                        <a:srgbClr val="D5DDE5"/>
+                      </a:solidFill>
+                      <a:prstDash val="solid"/>
+                      <a:round/>
+                      <a:headEnd type="none" w="med" len="med"/>
+                      <a:tailEnd type="none" w="med" len="med"/>
+                    </a:lnL>
+                    <a:lnR w="6350" cap="flat" cmpd="sng" algn="ctr">
+                      <a:solidFill>
+                        <a:srgbClr val="D5DDE5"/>
+                      </a:solidFill>
+                      <a:prstDash val="solid"/>
+                      <a:round/>
+                      <a:headEnd type="none" w="med" len="med"/>
+                      <a:tailEnd type="none" w="med" len="med"/>
+                    </a:lnR>
+                    <a:lnT w="6350" cap="flat" cmpd="sng" algn="ctr">
+                      <a:solidFill>
+                        <a:srgbClr val="D5DDE5"/>
+                      </a:solidFill>
+                      <a:prstDash val="solid"/>
+                      <a:round/>
+                      <a:headEnd type="none" w="med" len="med"/>
+                      <a:tailEnd type="none" w="med" len="med"/>
+                    </a:lnT>
+                    <a:lnB w="6350" cap="flat" cmpd="sng" algn="ctr">
+                      <a:solidFill>
+                        <a:srgbClr val="D5DDE5"/>
+                      </a:solidFill>
+                      <a:prstDash val="solid"/>
+                      <a:round/>
+                      <a:headEnd type="none" w="med" len="med"/>
+                      <a:tailEnd type="none" w="med" len="med"/>
+                    </a:lnB>
+                  </a:tcPr>
+                </a:tc>
+                <a:tc>
+                  <a:txBody>
+                    <a:bodyPr/>
+                    <a:lstStyle/>
+                    <a:p>
+                      <a:pPr algn="ctr" indent="0" marL="0">
+                        <a:buNone/>
+                      </a:pPr>
+                      <a:r>
+                        <a:rPr lang="en-US" sz="1400" dirty="0">
+                          <a:solidFill>
+                            <a:srgbClr val="1E293B"/>
+                          </a:solidFill>
+                          <a:latin typeface="Calibri" pitchFamily="34" charset="0"/>
+                          <a:ea typeface="Calibri" pitchFamily="34" charset="-122"/>
+                          <a:cs typeface="Calibri" pitchFamily="34" charset="-120"/>
+                        </a:rPr>
+                        <a:t>2018</a:t>
+                      </a:r>
+                      <a:endParaRPr lang="en-US" sz="1400" dirty="0">
+                        <a:latin typeface="Calibri" charset="0"/>
+                        <a:ea typeface="Calibri" charset="0"/>
+                        <a:cs typeface="Calibri" charset="0"/>
+                      </a:endParaRPr>
+                    </a:p>
+                  </a:txBody>
+                  <a:tcPr marL="91440" marR="91440" marT="45720" marB="45720" anchor="ctr">
+                    <a:lnL w="6350" cap="flat" cmpd="sng" algn="ctr">
+                      <a:solidFill>
+                        <a:srgbClr val="D5DDE5"/>
+                      </a:solidFill>
+                      <a:prstDash val="solid"/>
+                      <a:round/>
+                      <a:headEnd type="none" w="med" len="med"/>
+                      <a:tailEnd type="none" w="med" len="med"/>
+                    </a:lnL>
+                    <a:lnR w="6350" cap="flat" cmpd="sng" algn="ctr">
+                      <a:solidFill>
+                        <a:srgbClr val="D5DDE5"/>
+                      </a:solidFill>
+                      <a:prstDash val="solid"/>
+                      <a:round/>
+                      <a:headEnd type="none" w="med" len="med"/>
+                      <a:tailEnd type="none" w="med" len="med"/>
+                    </a:lnR>
+                    <a:lnT w="6350" cap="flat" cmpd="sng" algn="ctr">
+                      <a:solidFill>
+                        <a:srgbClr val="D5DDE5"/>
+                      </a:solidFill>
+                      <a:prstDash val="solid"/>
+                      <a:round/>
+                      <a:headEnd type="none" w="med" len="med"/>
+                      <a:tailEnd type="none" w="med" len="med"/>
+                    </a:lnT>
+                    <a:lnB w="6350" cap="flat" cmpd="sng" algn="ctr">
+                      <a:solidFill>
+                        <a:srgbClr val="D5DDE5"/>
+                      </a:solidFill>
+                      <a:prstDash val="solid"/>
+                      <a:round/>
+                      <a:headEnd type="none" w="med" len="med"/>
+                      <a:tailEnd type="none" w="med" len="med"/>
+                    </a:lnB>
+                  </a:tcPr>
+                </a:tc>
+                <a:tc>
+                  <a:txBody>
+                    <a:bodyPr/>
+                    <a:lstStyle/>
+                    <a:p>
+                      <a:pPr algn="ctr" indent="0" marL="0">
+                        <a:buNone/>
+                      </a:pPr>
+                      <a:r>
+                        <a:rPr lang="en-US" sz="1400" dirty="0">
+                          <a:solidFill>
+                            <a:srgbClr val="1E293B"/>
+                          </a:solidFill>
+                          <a:latin typeface="Calibri" pitchFamily="34" charset="0"/>
+                          <a:ea typeface="Calibri" pitchFamily="34" charset="-122"/>
+                          <a:cs typeface="Calibri" pitchFamily="34" charset="-120"/>
+                        </a:rPr>
+                        <a:t>201,099</a:t>
+                      </a:r>
+                      <a:endParaRPr lang="en-US" sz="1400" dirty="0">
+                        <a:latin typeface="Calibri" charset="0"/>
+                        <a:ea typeface="Calibri" charset="0"/>
+                        <a:cs typeface="Calibri" charset="0"/>
+                      </a:endParaRPr>
+                    </a:p>
+                  </a:txBody>
+                  <a:tcPr marL="91440" marR="91440" marT="45720" marB="45720" anchor="ctr">
+                    <a:lnL w="6350" cap="flat" cmpd="sng" algn="ctr">
+                      <a:solidFill>
+                        <a:srgbClr val="D5DDE5"/>
+                      </a:solidFill>
+                      <a:prstDash val="solid"/>
+                      <a:round/>
+                      <a:headEnd type="none" w="med" len="med"/>
+                      <a:tailEnd type="none" w="med" len="med"/>
+                    </a:lnL>
+                    <a:lnR w="6350" cap="flat" cmpd="sng" algn="ctr">
+                      <a:solidFill>
+                        <a:srgbClr val="D5DDE5"/>
+                      </a:solidFill>
+                      <a:prstDash val="solid"/>
+                      <a:round/>
+                      <a:headEnd type="none" w="med" len="med"/>
+                      <a:tailEnd type="none" w="med" len="med"/>
+                    </a:lnR>
+                    <a:lnT w="6350" cap="flat" cmpd="sng" algn="ctr">
+                      <a:solidFill>
+                        <a:srgbClr val="D5DDE5"/>
+                      </a:solidFill>
+                      <a:prstDash val="solid"/>
+                      <a:round/>
+                      <a:headEnd type="none" w="med" len="med"/>
+                      <a:tailEnd type="none" w="med" len="med"/>
+                    </a:lnT>
+                    <a:lnB w="6350" cap="flat" cmpd="sng" algn="ctr">
+                      <a:solidFill>
+                        <a:srgbClr val="D5DDE5"/>
+                      </a:solidFill>
+                      <a:prstDash val="solid"/>
+                      <a:round/>
+                      <a:headEnd type="none" w="med" len="med"/>
+                      <a:tailEnd type="none" w="med" len="med"/>
+                    </a:lnB>
+                  </a:tcPr>
+                </a:tc>
+                <a:tc>
+                  <a:txBody>
+                    <a:bodyPr/>
+                    <a:lstStyle/>
+                    <a:p>
+                      <a:pPr algn="ctr" indent="0" marL="0">
+                        <a:buNone/>
+                      </a:pPr>
+                      <a:r>
+                        <a:rPr lang="en-US" sz="1400" dirty="0">
+                          <a:solidFill>
+                            <a:srgbClr val="1E293B"/>
+                          </a:solidFill>
+                          <a:latin typeface="Calibri" pitchFamily="34" charset="0"/>
+                          <a:ea typeface="Calibri" pitchFamily="34" charset="-122"/>
+                          <a:cs typeface="Calibri" pitchFamily="34" charset="-120"/>
+                        </a:rPr>
+                        <a:t>61.4%</a:t>
+                      </a:r>
+                      <a:endParaRPr lang="en-US" sz="1400" dirty="0">
+                        <a:latin typeface="Calibri" charset="0"/>
+                        <a:ea typeface="Calibri" charset="0"/>
+                        <a:cs typeface="Calibri" charset="0"/>
+                      </a:endParaRPr>
+                    </a:p>
+                  </a:txBody>
+                  <a:tcPr marL="91440" marR="91440" marT="45720" marB="45720" anchor="ctr">
+                    <a:lnL w="6350" cap="flat" cmpd="sng" algn="ctr">
+                      <a:solidFill>
+                        <a:srgbClr val="D5DDE5"/>
+                      </a:solidFill>
+                      <a:prstDash val="solid"/>
+                      <a:round/>
+                      <a:headEnd type="none" w="med" len="med"/>
+                      <a:tailEnd type="none" w="med" len="med"/>
+                    </a:lnL>
+                    <a:lnR w="6350" cap="flat" cmpd="sng" algn="ctr">
+                      <a:solidFill>
+                        <a:srgbClr val="D5DDE5"/>
+                      </a:solidFill>
+                      <a:prstDash val="solid"/>
+                      <a:round/>
+                      <a:headEnd type="none" w="med" len="med"/>
+                      <a:tailEnd type="none" w="med" len="med"/>
+                    </a:lnR>
+                    <a:lnT w="6350" cap="flat" cmpd="sng" algn="ctr">
+                      <a:solidFill>
+                        <a:srgbClr val="D5DDE5"/>
+                      </a:solidFill>
+                      <a:prstDash val="solid"/>
+                      <a:round/>
+                      <a:headEnd type="none" w="med" len="med"/>
+                      <a:tailEnd type="none" w="med" len="med"/>
+                    </a:lnT>
+                    <a:lnB w="6350" cap="flat" cmpd="sng" algn="ctr">
+                      <a:solidFill>
+                        <a:srgbClr val="D5DDE5"/>
+                      </a:solidFill>
+                      <a:prstDash val="solid"/>
+                      <a:round/>
+                      <a:headEnd type="none" w="med" len="med"/>
+                      <a:tailEnd type="none" w="med" len="med"/>
+                    </a:lnB>
+                  </a:tcPr>
+                </a:tc>
+                <a:tc>
+                  <a:txBody>
+                    <a:bodyPr/>
+                    <a:lstStyle/>
+                    <a:p>
+                      <a:pPr algn="ctr" indent="0" marL="0">
+                        <a:buNone/>
+                      </a:pPr>
+                      <a:r>
+                        <a:rPr lang="en-US" sz="1400" dirty="0">
+                          <a:solidFill>
+                            <a:srgbClr val="1E293B"/>
+                          </a:solidFill>
+                          <a:latin typeface="Calibri" pitchFamily="34" charset="0"/>
+                          <a:ea typeface="Calibri" pitchFamily="34" charset="-122"/>
+                          <a:cs typeface="Calibri" pitchFamily="34" charset="-120"/>
+                        </a:rPr>
+                        <a:t>91.5%</a:t>
+                      </a:r>
+                      <a:endParaRPr lang="en-US" sz="1400" dirty="0">
+                        <a:latin typeface="Calibri" charset="0"/>
+                        <a:ea typeface="Calibri" charset="0"/>
+                        <a:cs typeface="Calibri" charset="0"/>
+                      </a:endParaRPr>
+                    </a:p>
+                  </a:txBody>
+                  <a:tcPr marL="91440" marR="91440" marT="45720" marB="45720" anchor="ctr">
+                    <a:lnL w="6350" cap="flat" cmpd="sng" algn="ctr">
+                      <a:solidFill>
+                        <a:srgbClr val="D5DDE5"/>
+                      </a:solidFill>
+                      <a:prstDash val="solid"/>
+                      <a:round/>
+                      <a:headEnd type="none" w="med" len="med"/>
+                      <a:tailEnd type="none" w="med" len="med"/>
+                    </a:lnL>
+                    <a:lnR w="6350" cap="flat" cmpd="sng" algn="ctr">
+                      <a:solidFill>
+                        <a:srgbClr val="D5DDE5"/>
+                      </a:solidFill>
+                      <a:prstDash val="solid"/>
+                      <a:round/>
+                      <a:headEnd type="none" w="med" len="med"/>
+                      <a:tailEnd type="none" w="med" len="med"/>
+                    </a:lnR>
+                    <a:lnT w="6350" cap="flat" cmpd="sng" algn="ctr">
+                      <a:solidFill>
+                        <a:srgbClr val="D5DDE5"/>
+                      </a:solidFill>
+                      <a:prstDash val="solid"/>
+                      <a:round/>
+                      <a:headEnd type="none" w="med" len="med"/>
+                      <a:tailEnd type="none" w="med" len="med"/>
+                    </a:lnT>
+                    <a:lnB w="6350" cap="flat" cmpd="sng" algn="ctr">
+                      <a:solidFill>
+                        <a:srgbClr val="D5DDE5"/>
+                      </a:solidFill>
+                      <a:prstDash val="solid"/>
+                      <a:round/>
+                      <a:headEnd type="none" w="med" len="med"/>
+                      <a:tailEnd type="none" w="med" len="med"/>
+                    </a:lnB>
+                  </a:tcPr>
+                </a:tc>
+              </a:tr>
+              <a:tr h="475488">
+                <a:tc>
+                  <a:txBody>
+                    <a:bodyPr/>
+                    <a:lstStyle/>
+                    <a:p>
+                      <a:pPr algn="l" indent="0" marL="0">
+                        <a:buNone/>
+                      </a:pPr>
+                      <a:r>
+                        <a:rPr lang="en-US" sz="1400" dirty="0">
+                          <a:solidFill>
+                            <a:srgbClr val="1E293B"/>
+                          </a:solidFill>
+                          <a:latin typeface="Calibri" pitchFamily="34" charset="0"/>
+                          <a:ea typeface="Calibri" pitchFamily="34" charset="-122"/>
+                          <a:cs typeface="Calibri" pitchFamily="34" charset="-120"/>
+                        </a:rPr>
+                        <a:t>MCLDNN</a:t>
+                      </a:r>
+                      <a:endParaRPr lang="en-US" sz="1400" dirty="0">
+                        <a:latin typeface="Calibri" charset="0"/>
+                        <a:ea typeface="Calibri" charset="0"/>
+                        <a:cs typeface="Calibri" charset="0"/>
+                      </a:endParaRPr>
+                    </a:p>
+                  </a:txBody>
+                  <a:tcPr marL="91440" marR="91440" marT="45720" marB="45720" anchor="ctr">
+                    <a:lnL w="6350" cap="flat" cmpd="sng" algn="ctr">
+                      <a:solidFill>
+                        <a:srgbClr val="D5DDE5"/>
+                      </a:solidFill>
+                      <a:prstDash val="solid"/>
+                      <a:round/>
+                      <a:headEnd type="none" w="med" len="med"/>
+                      <a:tailEnd type="none" w="med" len="med"/>
+                    </a:lnL>
+                    <a:lnR w="6350" cap="flat" cmpd="sng" algn="ctr">
+                      <a:solidFill>
+                        <a:srgbClr val="D5DDE5"/>
+                      </a:solidFill>
+                      <a:prstDash val="solid"/>
+                      <a:round/>
+                      <a:headEnd type="none" w="med" len="med"/>
+                      <a:tailEnd type="none" w="med" len="med"/>
+                    </a:lnR>
+                    <a:lnT w="6350" cap="flat" cmpd="sng" algn="ctr">
+                      <a:solidFill>
+                        <a:srgbClr val="D5DDE5"/>
+                      </a:solidFill>
+                      <a:prstDash val="solid"/>
+                      <a:round/>
+                      <a:headEnd type="none" w="med" len="med"/>
+                      <a:tailEnd type="none" w="med" len="med"/>
+                    </a:lnT>
+                    <a:lnB w="6350" cap="flat" cmpd="sng" algn="ctr">
+                      <a:solidFill>
+                        <a:srgbClr val="D5DDE5"/>
+                      </a:solidFill>
+                      <a:prstDash val="solid"/>
+                      <a:round/>
+                      <a:headEnd type="none" w="med" len="med"/>
+                      <a:tailEnd type="none" w="med" len="med"/>
+                    </a:lnB>
+                  </a:tcPr>
+                </a:tc>
+                <a:tc>
+                  <a:txBody>
+                    <a:bodyPr/>
+                    <a:lstStyle/>
+                    <a:p>
+                      <a:pPr algn="ctr" indent="0" marL="0">
+                        <a:buNone/>
+                      </a:pPr>
+                      <a:r>
+                        <a:rPr lang="en-US" sz="1400" dirty="0">
+                          <a:solidFill>
+                            <a:srgbClr val="1E293B"/>
+                          </a:solidFill>
+                          <a:latin typeface="Calibri" pitchFamily="34" charset="0"/>
+                          <a:ea typeface="Calibri" pitchFamily="34" charset="-122"/>
+                          <a:cs typeface="Calibri" pitchFamily="34" charset="-120"/>
+                        </a:rPr>
+                        <a:t>2020</a:t>
+                      </a:r>
+                      <a:endParaRPr lang="en-US" sz="1400" dirty="0">
+                        <a:latin typeface="Calibri" charset="0"/>
+                        <a:ea typeface="Calibri" charset="0"/>
+                        <a:cs typeface="Calibri" charset="0"/>
+                      </a:endParaRPr>
+                    </a:p>
+                  </a:txBody>
+                  <a:tcPr marL="91440" marR="91440" marT="45720" marB="45720" anchor="ctr">
+                    <a:lnL w="6350" cap="flat" cmpd="sng" algn="ctr">
+                      <a:solidFill>
+                        <a:srgbClr val="D5DDE5"/>
+                      </a:solidFill>
+                      <a:prstDash val="solid"/>
+                      <a:round/>
+                      <a:headEnd type="none" w="med" len="med"/>
+                      <a:tailEnd type="none" w="med" len="med"/>
+                    </a:lnL>
+                    <a:lnR w="6350" cap="flat" cmpd="sng" algn="ctr">
+                      <a:solidFill>
+                        <a:srgbClr val="D5DDE5"/>
+                      </a:solidFill>
+                      <a:prstDash val="solid"/>
+                      <a:round/>
+                      <a:headEnd type="none" w="med" len="med"/>
+                      <a:tailEnd type="none" w="med" len="med"/>
+                    </a:lnR>
+                    <a:lnT w="6350" cap="flat" cmpd="sng" algn="ctr">
+                      <a:solidFill>
+                        <a:srgbClr val="D5DDE5"/>
+                      </a:solidFill>
+                      <a:prstDash val="solid"/>
+                      <a:round/>
+                      <a:headEnd type="none" w="med" len="med"/>
+                      <a:tailEnd type="none" w="med" len="med"/>
+                    </a:lnT>
+                    <a:lnB w="6350" cap="flat" cmpd="sng" algn="ctr">
+                      <a:solidFill>
+                        <a:srgbClr val="D5DDE5"/>
+                      </a:solidFill>
+                      <a:prstDash val="solid"/>
+                      <a:round/>
+                      <a:headEnd type="none" w="med" len="med"/>
+                      <a:tailEnd type="none" w="med" len="med"/>
+                    </a:lnB>
+                  </a:tcPr>
+                </a:tc>
+                <a:tc>
+                  <a:txBody>
+                    <a:bodyPr/>
+                    <a:lstStyle/>
+                    <a:p>
+                      <a:pPr algn="ctr" indent="0" marL="0">
+                        <a:buNone/>
+                      </a:pPr>
+                      <a:r>
+                        <a:rPr lang="en-US" sz="1400" dirty="0">
+                          <a:solidFill>
+                            <a:srgbClr val="1E293B"/>
+                          </a:solidFill>
+                          <a:latin typeface="Calibri" pitchFamily="34" charset="0"/>
+                          <a:ea typeface="Calibri" pitchFamily="34" charset="-122"/>
+                          <a:cs typeface="Calibri" pitchFamily="34" charset="-120"/>
+                        </a:rPr>
+                        <a:t>406,199</a:t>
+                      </a:r>
+                      <a:endParaRPr lang="en-US" sz="1400" dirty="0">
+                        <a:latin typeface="Calibri" charset="0"/>
+                        <a:ea typeface="Calibri" charset="0"/>
+                        <a:cs typeface="Calibri" charset="0"/>
+                      </a:endParaRPr>
+                    </a:p>
+                  </a:txBody>
+                  <a:tcPr marL="91440" marR="91440" marT="45720" marB="45720" anchor="ctr">
+                    <a:lnL w="6350" cap="flat" cmpd="sng" algn="ctr">
+                      <a:solidFill>
+                        <a:srgbClr val="D5DDE5"/>
+                      </a:solidFill>
+                      <a:prstDash val="solid"/>
+                      <a:round/>
+                      <a:headEnd type="none" w="med" len="med"/>
+                      <a:tailEnd type="none" w="med" len="med"/>
+                    </a:lnL>
+                    <a:lnR w="6350" cap="flat" cmpd="sng" algn="ctr">
+                      <a:solidFill>
+                        <a:srgbClr val="D5DDE5"/>
+                      </a:solidFill>
+                      <a:prstDash val="solid"/>
+                      <a:round/>
+                      <a:headEnd type="none" w="med" len="med"/>
+                      <a:tailEnd type="none" w="med" len="med"/>
+                    </a:lnR>
+                    <a:lnT w="6350" cap="flat" cmpd="sng" algn="ctr">
+                      <a:solidFill>
+                        <a:srgbClr val="D5DDE5"/>
+                      </a:solidFill>
+                      <a:prstDash val="solid"/>
+                      <a:round/>
+                      <a:headEnd type="none" w="med" len="med"/>
+                      <a:tailEnd type="none" w="med" len="med"/>
+                    </a:lnT>
+                    <a:lnB w="6350" cap="flat" cmpd="sng" algn="ctr">
+                      <a:solidFill>
+                        <a:srgbClr val="D5DDE5"/>
+                      </a:solidFill>
+                      <a:prstDash val="solid"/>
+                      <a:round/>
+                      <a:headEnd type="none" w="med" len="med"/>
+                      <a:tailEnd type="none" w="med" len="med"/>
+                    </a:lnB>
+                  </a:tcPr>
+                </a:tc>
+                <a:tc>
+                  <a:txBody>
+                    <a:bodyPr/>
+                    <a:lstStyle/>
+                    <a:p>
+                      <a:pPr algn="ctr" indent="0" marL="0">
+                        <a:buNone/>
+                      </a:pPr>
+                      <a:r>
+                        <a:rPr lang="en-US" sz="1400" dirty="0">
+                          <a:solidFill>
+                            <a:srgbClr val="1E293B"/>
+                          </a:solidFill>
+                          <a:latin typeface="Calibri" pitchFamily="34" charset="0"/>
+                          <a:ea typeface="Calibri" pitchFamily="34" charset="-122"/>
+                          <a:cs typeface="Calibri" pitchFamily="34" charset="-120"/>
+                        </a:rPr>
+                        <a:t>61.4%</a:t>
+                      </a:r>
+                      <a:endParaRPr lang="en-US" sz="1400" dirty="0">
+                        <a:latin typeface="Calibri" charset="0"/>
+                        <a:ea typeface="Calibri" charset="0"/>
+                        <a:cs typeface="Calibri" charset="0"/>
+                      </a:endParaRPr>
+                    </a:p>
+                  </a:txBody>
+                  <a:tcPr marL="91440" marR="91440" marT="45720" marB="45720" anchor="ctr">
+                    <a:lnL w="6350" cap="flat" cmpd="sng" algn="ctr">
+                      <a:solidFill>
+                        <a:srgbClr val="D5DDE5"/>
+                      </a:solidFill>
+                      <a:prstDash val="solid"/>
+                      <a:round/>
+                      <a:headEnd type="none" w="med" len="med"/>
+                      <a:tailEnd type="none" w="med" len="med"/>
+                    </a:lnL>
+                    <a:lnR w="6350" cap="flat" cmpd="sng" algn="ctr">
+                      <a:solidFill>
+                        <a:srgbClr val="D5DDE5"/>
+                      </a:solidFill>
+                      <a:prstDash val="solid"/>
+                      <a:round/>
+                      <a:headEnd type="none" w="med" len="med"/>
+                      <a:tailEnd type="none" w="med" len="med"/>
+                    </a:lnR>
+                    <a:lnT w="6350" cap="flat" cmpd="sng" algn="ctr">
+                      <a:solidFill>
+                        <a:srgbClr val="D5DDE5"/>
+                      </a:solidFill>
+                      <a:prstDash val="solid"/>
+                      <a:round/>
+                      <a:headEnd type="none" w="med" len="med"/>
+                      <a:tailEnd type="none" w="med" len="med"/>
+                    </a:lnT>
+                    <a:lnB w="6350" cap="flat" cmpd="sng" algn="ctr">
+                      <a:solidFill>
+                        <a:srgbClr val="D5DDE5"/>
+                      </a:solidFill>
+                      <a:prstDash val="solid"/>
+                      <a:round/>
+                      <a:headEnd type="none" w="med" len="med"/>
+                      <a:tailEnd type="none" w="med" len="med"/>
+                    </a:lnB>
+                  </a:tcPr>
+                </a:tc>
+                <a:tc>
+                  <a:txBody>
+                    <a:bodyPr/>
+                    <a:lstStyle/>
+                    <a:p>
+                      <a:pPr algn="ctr" indent="0" marL="0">
+                        <a:buNone/>
+                      </a:pPr>
+                      <a:r>
+                        <a:rPr lang="en-US" sz="1400" dirty="0">
+                          <a:solidFill>
+                            <a:srgbClr val="1E293B"/>
+                          </a:solidFill>
+                          <a:latin typeface="Calibri" pitchFamily="34" charset="0"/>
+                          <a:ea typeface="Calibri" pitchFamily="34" charset="-122"/>
+                          <a:cs typeface="Calibri" pitchFamily="34" charset="-120"/>
+                        </a:rPr>
+                        <a:t>91.1%</a:t>
+                      </a:r>
+                      <a:endParaRPr lang="en-US" sz="1400" dirty="0">
+                        <a:latin typeface="Calibri" charset="0"/>
+                        <a:ea typeface="Calibri" charset="0"/>
+                        <a:cs typeface="Calibri" charset="0"/>
+                      </a:endParaRPr>
+                    </a:p>
+                  </a:txBody>
+                  <a:tcPr marL="91440" marR="91440" marT="45720" marB="45720" anchor="ctr">
+                    <a:lnL w="6350" cap="flat" cmpd="sng" algn="ctr">
+                      <a:solidFill>
+                        <a:srgbClr val="D5DDE5"/>
+                      </a:solidFill>
+                      <a:prstDash val="solid"/>
+                      <a:round/>
+                      <a:headEnd type="none" w="med" len="med"/>
+                      <a:tailEnd type="none" w="med" len="med"/>
+                    </a:lnL>
+                    <a:lnR w="6350" cap="flat" cmpd="sng" algn="ctr">
+                      <a:solidFill>
+                        <a:srgbClr val="D5DDE5"/>
+                      </a:solidFill>
+                      <a:prstDash val="solid"/>
+                      <a:round/>
+                      <a:headEnd type="none" w="med" len="med"/>
+                      <a:tailEnd type="none" w="med" len="med"/>
+                    </a:lnR>
+                    <a:lnT w="6350" cap="flat" cmpd="sng" algn="ctr">
+                      <a:solidFill>
+                        <a:srgbClr val="D5DDE5"/>
+                      </a:solidFill>
+                      <a:prstDash val="solid"/>
+                      <a:round/>
+                      <a:headEnd type="none" w="med" len="med"/>
+                      <a:tailEnd type="none" w="med" len="med"/>
+                    </a:lnT>
+                    <a:lnB w="6350" cap="flat" cmpd="sng" algn="ctr">
+                      <a:solidFill>
+                        <a:srgbClr val="D5DDE5"/>
+                      </a:solidFill>
+                      <a:prstDash val="solid"/>
+                      <a:round/>
+                      <a:headEnd type="none" w="med" len="med"/>
+                      <a:tailEnd type="none" w="med" len="med"/>
+                    </a:lnB>
+                  </a:tcPr>
+                </a:tc>
+              </a:tr>
+              <a:tr h="475488">
+                <a:tc>
+                  <a:txBody>
+                    <a:bodyPr/>
+                    <a:lstStyle/>
+                    <a:p>
+                      <a:pPr algn="l" indent="0" marL="0">
+                        <a:buNone/>
+                      </a:pPr>
+                      <a:r>
+                        <a:rPr lang="en-US" sz="1400" dirty="0">
+                          <a:solidFill>
+                            <a:srgbClr val="1E293B"/>
+                          </a:solidFill>
+                          <a:latin typeface="Calibri" pitchFamily="34" charset="0"/>
+                          <a:ea typeface="Calibri" pitchFamily="34" charset="-122"/>
+                          <a:cs typeface="Calibri" pitchFamily="34" charset="-120"/>
+                        </a:rPr>
+                        <a:t>PET-CGDNN</a:t>
+                      </a:r>
+                      <a:endParaRPr lang="en-US" sz="1400" dirty="0">
+                        <a:latin typeface="Calibri" charset="0"/>
+                        <a:ea typeface="Calibri" charset="0"/>
+                        <a:cs typeface="Calibri" charset="0"/>
+                      </a:endParaRPr>
+                    </a:p>
+                  </a:txBody>
+                  <a:tcPr marL="91440" marR="91440" marT="45720" marB="45720" anchor="ctr">
+                    <a:lnL w="6350" cap="flat" cmpd="sng" algn="ctr">
+                      <a:solidFill>
+                        <a:srgbClr val="D5DDE5"/>
+                      </a:solidFill>
+                      <a:prstDash val="solid"/>
+                      <a:round/>
+                      <a:headEnd type="none" w="med" len="med"/>
+                      <a:tailEnd type="none" w="med" len="med"/>
+                    </a:lnL>
+                    <a:lnR w="6350" cap="flat" cmpd="sng" algn="ctr">
+                      <a:solidFill>
+                        <a:srgbClr val="D5DDE5"/>
+                      </a:solidFill>
+                      <a:prstDash val="solid"/>
+                      <a:round/>
+                      <a:headEnd type="none" w="med" len="med"/>
+                      <a:tailEnd type="none" w="med" len="med"/>
+                    </a:lnR>
+                    <a:lnT w="6350" cap="flat" cmpd="sng" algn="ctr">
+                      <a:solidFill>
+                        <a:srgbClr val="D5DDE5"/>
+                      </a:solidFill>
+                      <a:prstDash val="solid"/>
+                      <a:round/>
+                      <a:headEnd type="none" w="med" len="med"/>
+                      <a:tailEnd type="none" w="med" len="med"/>
+                    </a:lnT>
+                    <a:lnB w="6350" cap="flat" cmpd="sng" algn="ctr">
+                      <a:solidFill>
+                        <a:srgbClr val="D5DDE5"/>
+                      </a:solidFill>
+                      <a:prstDash val="solid"/>
+                      <a:round/>
+                      <a:headEnd type="none" w="med" len="med"/>
+                      <a:tailEnd type="none" w="med" len="med"/>
+                    </a:lnB>
+                  </a:tcPr>
+                </a:tc>
+                <a:tc>
+                  <a:txBody>
+                    <a:bodyPr/>
+                    <a:lstStyle/>
+                    <a:p>
+                      <a:pPr algn="ctr" indent="0" marL="0">
+                        <a:buNone/>
+                      </a:pPr>
+                      <a:r>
+                        <a:rPr lang="en-US" sz="1400" dirty="0">
+                          <a:solidFill>
+                            <a:srgbClr val="1E293B"/>
+                          </a:solidFill>
+                          <a:latin typeface="Calibri" pitchFamily="34" charset="0"/>
+                          <a:ea typeface="Calibri" pitchFamily="34" charset="-122"/>
+                          <a:cs typeface="Calibri" pitchFamily="34" charset="-120"/>
+                        </a:rPr>
+                        <a:t>2021</a:t>
+                      </a:r>
+                      <a:endParaRPr lang="en-US" sz="1400" dirty="0">
+                        <a:latin typeface="Calibri" charset="0"/>
+                        <a:ea typeface="Calibri" charset="0"/>
+                        <a:cs typeface="Calibri" charset="0"/>
+                      </a:endParaRPr>
+                    </a:p>
+                  </a:txBody>
+                  <a:tcPr marL="91440" marR="91440" marT="45720" marB="45720" anchor="ctr">
+                    <a:lnL w="6350" cap="flat" cmpd="sng" algn="ctr">
+                      <a:solidFill>
+                        <a:srgbClr val="D5DDE5"/>
+                      </a:solidFill>
+                      <a:prstDash val="solid"/>
+                      <a:round/>
+                      <a:headEnd type="none" w="med" len="med"/>
+                      <a:tailEnd type="none" w="med" len="med"/>
+                    </a:lnL>
+                    <a:lnR w="6350" cap="flat" cmpd="sng" algn="ctr">
+                      <a:solidFill>
+                        <a:srgbClr val="D5DDE5"/>
+                      </a:solidFill>
+                      <a:prstDash val="solid"/>
+                      <a:round/>
+                      <a:headEnd type="none" w="med" len="med"/>
+                      <a:tailEnd type="none" w="med" len="med"/>
+                    </a:lnR>
+                    <a:lnT w="6350" cap="flat" cmpd="sng" algn="ctr">
+                      <a:solidFill>
+                        <a:srgbClr val="D5DDE5"/>
+                      </a:solidFill>
+                      <a:prstDash val="solid"/>
+                      <a:round/>
+                      <a:headEnd type="none" w="med" len="med"/>
+                      <a:tailEnd type="none" w="med" len="med"/>
+                    </a:lnT>
+                    <a:lnB w="6350" cap="flat" cmpd="sng" algn="ctr">
+                      <a:solidFill>
+                        <a:srgbClr val="D5DDE5"/>
+                      </a:solidFill>
+                      <a:prstDash val="solid"/>
+                      <a:round/>
+                      <a:headEnd type="none" w="med" len="med"/>
+                      <a:tailEnd type="none" w="med" len="med"/>
+                    </a:lnB>
+                  </a:tcPr>
+                </a:tc>
+                <a:tc>
+                  <a:txBody>
+                    <a:bodyPr/>
+                    <a:lstStyle/>
+                    <a:p>
+                      <a:pPr algn="ctr" indent="0" marL="0">
+                        <a:buNone/>
+                      </a:pPr>
+                      <a:r>
+                        <a:rPr lang="en-US" sz="1400" dirty="0">
+                          <a:solidFill>
+                            <a:srgbClr val="1E293B"/>
+                          </a:solidFill>
+                          <a:latin typeface="Calibri" pitchFamily="34" charset="0"/>
+                          <a:ea typeface="Calibri" pitchFamily="34" charset="-122"/>
+                          <a:cs typeface="Calibri" pitchFamily="34" charset="-120"/>
+                        </a:rPr>
+                        <a:t>71,871</a:t>
+                      </a:r>
+                      <a:endParaRPr lang="en-US" sz="1400" dirty="0">
+                        <a:latin typeface="Calibri" charset="0"/>
+                        <a:ea typeface="Calibri" charset="0"/>
+                        <a:cs typeface="Calibri" charset="0"/>
+                      </a:endParaRPr>
+                    </a:p>
+                  </a:txBody>
+                  <a:tcPr marL="91440" marR="91440" marT="45720" marB="45720" anchor="ctr">
+                    <a:lnL w="6350" cap="flat" cmpd="sng" algn="ctr">
+                      <a:solidFill>
+                        <a:srgbClr val="D5DDE5"/>
+                      </a:solidFill>
+                      <a:prstDash val="solid"/>
+                      <a:round/>
+                      <a:headEnd type="none" w="med" len="med"/>
+                      <a:tailEnd type="none" w="med" len="med"/>
+                    </a:lnL>
+                    <a:lnR w="6350" cap="flat" cmpd="sng" algn="ctr">
+                      <a:solidFill>
+                        <a:srgbClr val="D5DDE5"/>
+                      </a:solidFill>
+                      <a:prstDash val="solid"/>
+                      <a:round/>
+                      <a:headEnd type="none" w="med" len="med"/>
+                      <a:tailEnd type="none" w="med" len="med"/>
+                    </a:lnR>
+                    <a:lnT w="6350" cap="flat" cmpd="sng" algn="ctr">
+                      <a:solidFill>
+                        <a:srgbClr val="D5DDE5"/>
+                      </a:solidFill>
+                      <a:prstDash val="solid"/>
+                      <a:round/>
+                      <a:headEnd type="none" w="med" len="med"/>
+                      <a:tailEnd type="none" w="med" len="med"/>
+                    </a:lnT>
+                    <a:lnB w="6350" cap="flat" cmpd="sng" algn="ctr">
+                      <a:solidFill>
+                        <a:srgbClr val="D5DDE5"/>
+                      </a:solidFill>
+                      <a:prstDash val="solid"/>
+                      <a:round/>
+                      <a:headEnd type="none" w="med" len="med"/>
+                      <a:tailEnd type="none" w="med" len="med"/>
+                    </a:lnB>
+                  </a:tcPr>
+                </a:tc>
+                <a:tc>
+                  <a:txBody>
+                    <a:bodyPr/>
+                    <a:lstStyle/>
+                    <a:p>
+                      <a:pPr algn="ctr" indent="0" marL="0">
+                        <a:buNone/>
+                      </a:pPr>
+                      <a:r>
+                        <a:rPr lang="en-US" sz="1400" dirty="0">
+                          <a:solidFill>
+                            <a:srgbClr val="1E293B"/>
+                          </a:solidFill>
+                          <a:latin typeface="Calibri" pitchFamily="34" charset="0"/>
+                          <a:ea typeface="Calibri" pitchFamily="34" charset="-122"/>
+                          <a:cs typeface="Calibri" pitchFamily="34" charset="-120"/>
+                        </a:rPr>
+                        <a:t>61.0%</a:t>
+                      </a:r>
+                      <a:endParaRPr lang="en-US" sz="1400" dirty="0">
+                        <a:latin typeface="Calibri" charset="0"/>
+                        <a:ea typeface="Calibri" charset="0"/>
+                        <a:cs typeface="Calibri" charset="0"/>
+                      </a:endParaRPr>
+                    </a:p>
+                  </a:txBody>
+                  <a:tcPr marL="91440" marR="91440" marT="45720" marB="45720" anchor="ctr">
+                    <a:lnL w="6350" cap="flat" cmpd="sng" algn="ctr">
+                      <a:solidFill>
+                        <a:srgbClr val="D5DDE5"/>
+                      </a:solidFill>
+                      <a:prstDash val="solid"/>
+                      <a:round/>
+                      <a:headEnd type="none" w="med" len="med"/>
+                      <a:tailEnd type="none" w="med" len="med"/>
+                    </a:lnL>
+                    <a:lnR w="6350" cap="flat" cmpd="sng" algn="ctr">
+                      <a:solidFill>
+                        <a:srgbClr val="D5DDE5"/>
+                      </a:solidFill>
+                      <a:prstDash val="solid"/>
+                      <a:round/>
+                      <a:headEnd type="none" w="med" len="med"/>
+                      <a:tailEnd type="none" w="med" len="med"/>
+                    </a:lnR>
+                    <a:lnT w="6350" cap="flat" cmpd="sng" algn="ctr">
+                      <a:solidFill>
+                        <a:srgbClr val="D5DDE5"/>
+                      </a:solidFill>
+                      <a:prstDash val="solid"/>
+                      <a:round/>
+                      <a:headEnd type="none" w="med" len="med"/>
+                      <a:tailEnd type="none" w="med" len="med"/>
+                    </a:lnT>
+                    <a:lnB w="6350" cap="flat" cmpd="sng" algn="ctr">
+                      <a:solidFill>
+                        <a:srgbClr val="D5DDE5"/>
+                      </a:solidFill>
+                      <a:prstDash val="solid"/>
+                      <a:round/>
+                      <a:headEnd type="none" w="med" len="med"/>
+                      <a:tailEnd type="none" w="med" len="med"/>
+                    </a:lnB>
+                  </a:tcPr>
+                </a:tc>
+                <a:tc>
+                  <a:txBody>
+                    <a:bodyPr/>
+                    <a:lstStyle/>
+                    <a:p>
+                      <a:pPr algn="ctr" indent="0" marL="0">
+                        <a:buNone/>
+                      </a:pPr>
+                      <a:r>
+                        <a:rPr lang="en-US" sz="1400" dirty="0">
+                          <a:solidFill>
+                            <a:srgbClr val="1E293B"/>
+                          </a:solidFill>
+                          <a:latin typeface="Calibri" pitchFamily="34" charset="0"/>
+                          <a:ea typeface="Calibri" pitchFamily="34" charset="-122"/>
+                          <a:cs typeface="Calibri" pitchFamily="34" charset="-120"/>
+                        </a:rPr>
+                        <a:t>90.6%</a:t>
+                      </a:r>
+                      <a:endParaRPr lang="en-US" sz="1400" dirty="0">
+                        <a:latin typeface="Calibri" charset="0"/>
+                        <a:ea typeface="Calibri" charset="0"/>
+                        <a:cs typeface="Calibri" charset="0"/>
+                      </a:endParaRPr>
+                    </a:p>
+                  </a:txBody>
+                  <a:tcPr marL="91440" marR="91440" marT="45720" marB="45720" anchor="ctr">
+                    <a:lnL w="6350" cap="flat" cmpd="sng" algn="ctr">
+                      <a:solidFill>
+                        <a:srgbClr val="D5DDE5"/>
+                      </a:solidFill>
+                      <a:prstDash val="solid"/>
+                      <a:round/>
+                      <a:headEnd type="none" w="med" len="med"/>
+                      <a:tailEnd type="none" w="med" len="med"/>
+                    </a:lnL>
+                    <a:lnR w="6350" cap="flat" cmpd="sng" algn="ctr">
+                      <a:solidFill>
+                        <a:srgbClr val="D5DDE5"/>
+                      </a:solidFill>
+                      <a:prstDash val="solid"/>
+                      <a:round/>
+                      <a:headEnd type="none" w="med" len="med"/>
+                      <a:tailEnd type="none" w="med" len="med"/>
+                    </a:lnR>
+                    <a:lnT w="6350" cap="flat" cmpd="sng" algn="ctr">
+                      <a:solidFill>
+                        <a:srgbClr val="D5DDE5"/>
+                      </a:solidFill>
+                      <a:prstDash val="solid"/>
+                      <a:round/>
+                      <a:headEnd type="none" w="med" len="med"/>
+                      <a:tailEnd type="none" w="med" len="med"/>
+                    </a:lnT>
+                    <a:lnB w="6350" cap="flat" cmpd="sng" algn="ctr">
+                      <a:solidFill>
+                        <a:srgbClr val="D5DDE5"/>
+                      </a:solidFill>
+                      <a:prstDash val="solid"/>
+                      <a:round/>
+                      <a:headEnd type="none" w="med" len="med"/>
+                      <a:tailEnd type="none" w="med" len="med"/>
+                    </a:lnB>
+                  </a:tcPr>
+                </a:tc>
+              </a:tr>
+              <a:tr h="475488">
+                <a:tc>
+                  <a:txBody>
+                    <a:bodyPr/>
+                    <a:lstStyle/>
+                    <a:p>
+                      <a:pPr algn="l" indent="0" marL="0">
+                        <a:buNone/>
+                      </a:pPr>
+                      <a:r>
+                        <a:rPr lang="en-US" sz="1400" dirty="0">
+                          <a:solidFill>
+                            <a:srgbClr val="1E293B"/>
+                          </a:solidFill>
+                          <a:latin typeface="Calibri" pitchFamily="34" charset="0"/>
+                          <a:ea typeface="Calibri" pitchFamily="34" charset="-122"/>
+                          <a:cs typeface="Calibri" pitchFamily="34" charset="-120"/>
+                        </a:rPr>
+                        <a:t>VT-CNN2</a:t>
+                      </a:r>
+                      <a:endParaRPr lang="en-US" sz="1400" dirty="0">
+                        <a:latin typeface="Calibri" charset="0"/>
+                        <a:ea typeface="Calibri" charset="0"/>
+                        <a:cs typeface="Calibri" charset="0"/>
+                      </a:endParaRPr>
+                    </a:p>
+                  </a:txBody>
+                  <a:tcPr marL="91440" marR="91440" marT="45720" marB="45720" anchor="ctr">
+                    <a:lnL w="6350" cap="flat" cmpd="sng" algn="ctr">
+                      <a:solidFill>
+                        <a:srgbClr val="D5DDE5"/>
+                      </a:solidFill>
+                      <a:prstDash val="solid"/>
+                      <a:round/>
+                      <a:headEnd type="none" w="med" len="med"/>
+                      <a:tailEnd type="none" w="med" len="med"/>
+                    </a:lnL>
+                    <a:lnR w="6350" cap="flat" cmpd="sng" algn="ctr">
+                      <a:solidFill>
+                        <a:srgbClr val="D5DDE5"/>
+                      </a:solidFill>
+                      <a:prstDash val="solid"/>
+                      <a:round/>
+                      <a:headEnd type="none" w="med" len="med"/>
+                      <a:tailEnd type="none" w="med" len="med"/>
+                    </a:lnR>
+                    <a:lnT w="6350" cap="flat" cmpd="sng" algn="ctr">
+                      <a:solidFill>
+                        <a:srgbClr val="D5DDE5"/>
+                      </a:solidFill>
+                      <a:prstDash val="solid"/>
+                      <a:round/>
+                      <a:headEnd type="none" w="med" len="med"/>
+                      <a:tailEnd type="none" w="med" len="med"/>
+                    </a:lnT>
+                    <a:lnB w="6350" cap="flat" cmpd="sng" algn="ctr">
+                      <a:solidFill>
+                        <a:srgbClr val="D5DDE5"/>
+                      </a:solidFill>
+                      <a:prstDash val="solid"/>
+                      <a:round/>
+                      <a:headEnd type="none" w="med" len="med"/>
+                      <a:tailEnd type="none" w="med" len="med"/>
+                    </a:lnB>
+                  </a:tcPr>
+                </a:tc>
+                <a:tc>
+                  <a:txBody>
+                    <a:bodyPr/>
+                    <a:lstStyle/>
+                    <a:p>
+                      <a:pPr algn="ctr" indent="0" marL="0">
+                        <a:buNone/>
+                      </a:pPr>
+                      <a:r>
+                        <a:rPr lang="en-US" sz="1400" dirty="0">
+                          <a:solidFill>
+                            <a:srgbClr val="1E293B"/>
+                          </a:solidFill>
+                          <a:latin typeface="Calibri" pitchFamily="34" charset="0"/>
+                          <a:ea typeface="Calibri" pitchFamily="34" charset="-122"/>
+                          <a:cs typeface="Calibri" pitchFamily="34" charset="-120"/>
+                        </a:rPr>
+                        <a:t>2016</a:t>
+                      </a:r>
+                      <a:endParaRPr lang="en-US" sz="1400" dirty="0">
+                        <a:latin typeface="Calibri" charset="0"/>
+                        <a:ea typeface="Calibri" charset="0"/>
+                        <a:cs typeface="Calibri" charset="0"/>
+                      </a:endParaRPr>
+                    </a:p>
+                  </a:txBody>
+                  <a:tcPr marL="91440" marR="91440" marT="45720" marB="45720" anchor="ctr">
+                    <a:lnL w="6350" cap="flat" cmpd="sng" algn="ctr">
+                      <a:solidFill>
+                        <a:srgbClr val="D5DDE5"/>
+                      </a:solidFill>
+                      <a:prstDash val="solid"/>
+                      <a:round/>
+                      <a:headEnd type="none" w="med" len="med"/>
+                      <a:tailEnd type="none" w="med" len="med"/>
+                    </a:lnL>
+                    <a:lnR w="6350" cap="flat" cmpd="sng" algn="ctr">
+                      <a:solidFill>
+                        <a:srgbClr val="D5DDE5"/>
+                      </a:solidFill>
+                      <a:prstDash val="solid"/>
+                      <a:round/>
+                      <a:headEnd type="none" w="med" len="med"/>
+                      <a:tailEnd type="none" w="med" len="med"/>
+                    </a:lnR>
+                    <a:lnT w="6350" cap="flat" cmpd="sng" algn="ctr">
+                      <a:solidFill>
+                        <a:srgbClr val="D5DDE5"/>
+                      </a:solidFill>
+                      <a:prstDash val="solid"/>
+                      <a:round/>
+                      <a:headEnd type="none" w="med" len="med"/>
+                      <a:tailEnd type="none" w="med" len="med"/>
+                    </a:lnT>
+                    <a:lnB w="6350" cap="flat" cmpd="sng" algn="ctr">
+                      <a:solidFill>
+                        <a:srgbClr val="D5DDE5"/>
+                      </a:solidFill>
+                      <a:prstDash val="solid"/>
+                      <a:round/>
+                      <a:headEnd type="none" w="med" len="med"/>
+                      <a:tailEnd type="none" w="med" len="med"/>
+                    </a:lnB>
+                  </a:tcPr>
+                </a:tc>
+                <a:tc>
+                  <a:txBody>
+                    <a:bodyPr/>
+                    <a:lstStyle/>
+                    <a:p>
+                      <a:pPr algn="ctr" indent="0" marL="0">
+                        <a:buNone/>
+                      </a:pPr>
+                      <a:r>
+                        <a:rPr lang="en-US" sz="1400" dirty="0">
+                          <a:solidFill>
+                            <a:srgbClr val="1E293B"/>
+                          </a:solidFill>
+                          <a:latin typeface="Calibri" pitchFamily="34" charset="0"/>
+                          <a:ea typeface="Calibri" pitchFamily="34" charset="-122"/>
+                          <a:cs typeface="Calibri" pitchFamily="34" charset="-120"/>
+                        </a:rPr>
+                        <a:t>1,592,383</a:t>
+                      </a:r>
+                      <a:endParaRPr lang="en-US" sz="1400" dirty="0">
+                        <a:latin typeface="Calibri" charset="0"/>
+                        <a:ea typeface="Calibri" charset="0"/>
+                        <a:cs typeface="Calibri" charset="0"/>
+                      </a:endParaRPr>
+                    </a:p>
+                  </a:txBody>
+                  <a:tcPr marL="91440" marR="91440" marT="45720" marB="45720" anchor="ctr">
+                    <a:lnL w="6350" cap="flat" cmpd="sng" algn="ctr">
+                      <a:solidFill>
+                        <a:srgbClr val="D5DDE5"/>
+                      </a:solidFill>
+                      <a:prstDash val="solid"/>
+                      <a:round/>
+                      <a:headEnd type="none" w="med" len="med"/>
+                      <a:tailEnd type="none" w="med" len="med"/>
+                    </a:lnL>
+                    <a:lnR w="6350" cap="flat" cmpd="sng" algn="ctr">
+                      <a:solidFill>
+                        <a:srgbClr val="D5DDE5"/>
+                      </a:solidFill>
+                      <a:prstDash val="solid"/>
+                      <a:round/>
+                      <a:headEnd type="none" w="med" len="med"/>
+                      <a:tailEnd type="none" w="med" len="med"/>
+                    </a:lnR>
+                    <a:lnT w="6350" cap="flat" cmpd="sng" algn="ctr">
+                      <a:solidFill>
+                        <a:srgbClr val="D5DDE5"/>
+                      </a:solidFill>
+                      <a:prstDash val="solid"/>
+                      <a:round/>
+                      <a:headEnd type="none" w="med" len="med"/>
+                      <a:tailEnd type="none" w="med" len="med"/>
+                    </a:lnT>
+                    <a:lnB w="6350" cap="flat" cmpd="sng" algn="ctr">
+                      <a:solidFill>
+                        <a:srgbClr val="D5DDE5"/>
+                      </a:solidFill>
+                      <a:prstDash val="solid"/>
+                      <a:round/>
+                      <a:headEnd type="none" w="med" len="med"/>
+                      <a:tailEnd type="none" w="med" len="med"/>
+                    </a:lnB>
+                  </a:tcPr>
+                </a:tc>
+                <a:tc>
+                  <a:txBody>
+                    <a:bodyPr/>
+                    <a:lstStyle/>
+                    <a:p>
+                      <a:pPr algn="ctr" indent="0" marL="0">
+                        <a:buNone/>
+                      </a:pPr>
+                      <a:r>
+                        <a:rPr lang="en-US" sz="1400" dirty="0">
+                          <a:solidFill>
+                            <a:srgbClr val="1E293B"/>
+                          </a:solidFill>
+                          <a:latin typeface="Calibri" pitchFamily="34" charset="0"/>
+                          <a:ea typeface="Calibri" pitchFamily="34" charset="-122"/>
+                          <a:cs typeface="Calibri" pitchFamily="34" charset="-120"/>
+                        </a:rPr>
+                        <a:t>56.1%</a:t>
+                      </a:r>
+                      <a:endParaRPr lang="en-US" sz="1400" dirty="0">
+                        <a:latin typeface="Calibri" charset="0"/>
+                        <a:ea typeface="Calibri" charset="0"/>
+                        <a:cs typeface="Calibri" charset="0"/>
+                      </a:endParaRPr>
+                    </a:p>
+                  </a:txBody>
+                  <a:tcPr marL="91440" marR="91440" marT="45720" marB="45720" anchor="ctr">
+                    <a:lnL w="6350" cap="flat" cmpd="sng" algn="ctr">
+                      <a:solidFill>
+                        <a:srgbClr val="D5DDE5"/>
+                      </a:solidFill>
+                      <a:prstDash val="solid"/>
+                      <a:round/>
+                      <a:headEnd type="none" w="med" len="med"/>
+                      <a:tailEnd type="none" w="med" len="med"/>
+                    </a:lnL>
+                    <a:lnR w="6350" cap="flat" cmpd="sng" algn="ctr">
+                      <a:solidFill>
+                        <a:srgbClr val="D5DDE5"/>
+                      </a:solidFill>
+                      <a:prstDash val="solid"/>
+                      <a:round/>
+                      <a:headEnd type="none" w="med" len="med"/>
+                      <a:tailEnd type="none" w="med" len="med"/>
+                    </a:lnR>
+                    <a:lnT w="6350" cap="flat" cmpd="sng" algn="ctr">
+                      <a:solidFill>
+                        <a:srgbClr val="D5DDE5"/>
+                      </a:solidFill>
+                      <a:prstDash val="solid"/>
+                      <a:round/>
+                      <a:headEnd type="none" w="med" len="med"/>
+                      <a:tailEnd type="none" w="med" len="med"/>
+                    </a:lnT>
+                    <a:lnB w="6350" cap="flat" cmpd="sng" algn="ctr">
+                      <a:solidFill>
+                        <a:srgbClr val="D5DDE5"/>
+                      </a:solidFill>
+                      <a:prstDash val="solid"/>
+                      <a:round/>
+                      <a:headEnd type="none" w="med" len="med"/>
+                      <a:tailEnd type="none" w="med" len="med"/>
+                    </a:lnB>
+                  </a:tcPr>
+                </a:tc>
+                <a:tc>
+                  <a:txBody>
+                    <a:bodyPr/>
+                    <a:lstStyle/>
+                    <a:p>
+                      <a:pPr algn="ctr" indent="0" marL="0">
+                        <a:buNone/>
+                      </a:pPr>
+                      <a:r>
+                        <a:rPr lang="en-US" sz="1400" dirty="0">
+                          <a:solidFill>
+                            <a:srgbClr val="1E293B"/>
+                          </a:solidFill>
+                          <a:latin typeface="Calibri" pitchFamily="34" charset="0"/>
+                          <a:ea typeface="Calibri" pitchFamily="34" charset="-122"/>
+                          <a:cs typeface="Calibri" pitchFamily="34" charset="-120"/>
+                        </a:rPr>
+                        <a:t>82.0%</a:t>
+                      </a:r>
+                      <a:endParaRPr lang="en-US" sz="1400" dirty="0">
+                        <a:latin typeface="Calibri" charset="0"/>
+                        <a:ea typeface="Calibri" charset="0"/>
+                        <a:cs typeface="Calibri" charset="0"/>
+                      </a:endParaRPr>
+                    </a:p>
+                  </a:txBody>
+                  <a:tcPr marL="91440" marR="91440" marT="45720" marB="45720" anchor="ctr">
+                    <a:lnL w="6350" cap="flat" cmpd="sng" algn="ctr">
+                      <a:solidFill>
+                        <a:srgbClr val="D5DDE5"/>
+                      </a:solidFill>
+                      <a:prstDash val="solid"/>
+                      <a:round/>
+                      <a:headEnd type="none" w="med" len="med"/>
+                      <a:tailEnd type="none" w="med" len="med"/>
+                    </a:lnL>
+                    <a:lnR w="6350" cap="flat" cmpd="sng" algn="ctr">
+                      <a:solidFill>
+                        <a:srgbClr val="D5DDE5"/>
+                      </a:solidFill>
+                      <a:prstDash val="solid"/>
+                      <a:round/>
+                      <a:headEnd type="none" w="med" len="med"/>
+                      <a:tailEnd type="none" w="med" len="med"/>
+                    </a:lnR>
+                    <a:lnT w="6350" cap="flat" cmpd="sng" algn="ctr">
+                      <a:solidFill>
+                        <a:srgbClr val="D5DDE5"/>
+                      </a:solidFill>
+                      <a:prstDash val="solid"/>
+                      <a:round/>
+                      <a:headEnd type="none" w="med" len="med"/>
+                      <a:tailEnd type="none" w="med" len="med"/>
+                    </a:lnT>
+                    <a:lnB w="6350" cap="flat" cmpd="sng" algn="ctr">
+                      <a:solidFill>
+                        <a:srgbClr val="D5DDE5"/>
+                      </a:solidFill>
+                      <a:prstDash val="solid"/>
+                      <a:round/>
+                      <a:headEnd type="none" w="med" len="med"/>
+                      <a:tailEnd type="none" w="med" len="med"/>
+                    </a:lnB>
+                  </a:tcPr>
+                </a:tc>
+              </a:tr>
+            </a:tbl>
+          </a:graphicData>
+        </a:graphic>
+      </p:graphicFrame>
+      <p:sp>
+        <p:nvSpPr>
+          <p:cNvPr id="8" name="Text 5"/>
+          <p:cNvSpPr txBox="1"/>
+          <p:nvPr/>
+        </p:nvSpPr>
+        <p:spPr>
+          <a:xfrm>
+            <a:off x="548640" y="4800600"/>
+            <a:ext cx="6035040" cy="457200"/>
+          </a:xfrm>
+          <a:prstGeom prst="rect">
+            <a:avLst/>
+          </a:prstGeom>
+          <a:noFill/>
+          <a:ln/>
+        </p:spPr>
+        <p:txBody>
+          <a:bodyPr wrap="square" lIns="0" tIns="0" rIns="0" bIns="0" rtlCol="0" anchor="t"/>
+          <a:lstStyle/>
+          <a:p>
+            <a:pPr indent="0" marL="0">
+              <a:buNone/>
+            </a:pPr>
+            <a:r>
+              <a:rPr lang="en-US" sz="1100" i="1" dirty="0">
+                <a:solidFill>
+                  <a:srgbClr val="5B6B7F"/>
+                </a:solidFill>
+                <a:latin typeface="Calibri" pitchFamily="34" charset="0"/>
+                <a:ea typeface="Calibri" pitchFamily="34" charset="-122"/>
+                <a:cs typeface="Calibri" pitchFamily="34" charset="-120"/>
+              </a:rPr>
+              <a:t>Models from Zhang et al., Digital Signal Processing 2022 (their code, rewritten line by line).</a:t>
+            </a:r>
+            <a:endParaRPr lang="en-US" sz="1100" dirty="0"/>
+          </a:p>
+        </p:txBody>
+      </p:sp>
+      <p:pic>
+        <p:nvPicPr>
+          <p:cNvPr id="9" name="Image 0" descr="../figures/38_literature_2016.png">    </p:cNvPr>
+          <p:cNvPicPr>
+            <a:picLocks noChangeAspect="1"/>
+          </p:cNvPicPr>
+          <p:nvPr/>
+        </p:nvPicPr>
+        <p:blipFill>
+          <a:blip r:embed="rId1"/>
+          <a:stretch>
+            <a:fillRect/>
+          </a:stretch>
+        </p:blipFill>
+        <p:spPr>
+          <a:xfrm>
+            <a:off x="6812280" y="1828800"/>
+            <a:ext cx="4828032" cy="2682240"/>
+          </a:xfrm>
+          <a:prstGeom prst="rect">
+            <a:avLst/>
+          </a:prstGeom>
+        </p:spPr>
+      </p:pic>
+      <p:sp>
+        <p:nvSpPr>
+          <p:cNvPr id="10" name="Text 6"/>
+          <p:cNvSpPr txBox="1"/>
+          <p:nvPr/>
+        </p:nvSpPr>
+        <p:spPr>
+          <a:xfrm>
+            <a:off x="548640" y="5623560"/>
+            <a:ext cx="11091672" cy="548640"/>
+          </a:xfrm>
+          <a:prstGeom prst="rect">
+            <a:avLst/>
+          </a:prstGeom>
+          <a:noFill/>
+          <a:ln/>
+        </p:spPr>
+        <p:txBody>
+          <a:bodyPr wrap="square" lIns="0" tIns="0" rIns="0" bIns="0" rtlCol="0" anchor="t"/>
+          <a:lstStyle/>
+          <a:p>
+            <a:pPr indent="0" marL="0">
+              <a:buNone/>
+            </a:pPr>
+            <a:r>
+              <a:rPr lang="en-US" sz="1500" b="1" dirty="0">
+                <a:solidFill>
+                  <a:srgbClr val="1E293B"/>
+                </a:solidFill>
+                <a:latin typeface="Calibri" pitchFamily="34" charset="0"/>
+                <a:ea typeface="Calibri" pitchFamily="34" charset="-122"/>
+                <a:cs typeface="Calibri" pitchFamily="34" charset="-120"/>
+              </a:rPr>
+              <a:t>ICRNNA is first overall, but the best four are within 1.2 points.</a:t>
+            </a:r>
+            <a:pPr indent="0" marL="0">
+              <a:buNone/>
+            </a:pPr>
+            <a:r>
+              <a:rPr lang="en-US" sz="1500" dirty="0">
+                <a:solidFill>
+                  <a:srgbClr val="1E293B"/>
+                </a:solidFill>
+                <a:latin typeface="Calibri" pitchFamily="34" charset="0"/>
+                <a:ea typeface="Calibri" pitchFamily="34" charset="-122"/>
+                <a:cs typeface="Calibri" pitchFamily="34" charset="-120"/>
+              </a:rPr>
+              <a:t>  Above 10 dB they all stop near 91%: that limit is in the data, not the model.</a:t>
+            </a:r>
+            <a:endParaRPr lang="en-US" sz="1500" dirty="0"/>
+          </a:p>
+        </p:txBody>
+      </p:sp>
+      <p:sp>
+        <p:nvSpPr>
+          <p:cNvPr id="12" name="Text 7"/>
+          <p:cNvSpPr txBox="1"/>
+          <p:nvPr/>
+        </p:nvSpPr>
+        <p:spPr>
+          <a:xfrm>
+            <a:off x="11274552" y="6446520"/>
+            <a:ext cx="365760" cy="228600"/>
+          </a:xfrm>
+          <a:prstGeom prst="rect">
+            <a:avLst/>
+          </a:prstGeom>
+          <a:noFill/>
+          <a:ln/>
+        </p:spPr>
+        <p:txBody>
+          <a:bodyPr wrap="square" lIns="0" tIns="0" rIns="0" bIns="0" rtlCol="0" anchor="t"/>
+          <a:lstStyle/>
+          <a:p>
+            <a:pPr algn="r" indent="0" marL="0">
+              <a:buNone/>
+            </a:pPr>
+            <a:r>
+              <a:rPr lang="en-US" sz="1000" dirty="0">
+                <a:solidFill>
+                  <a:srgbClr val="5B6B7F"/>
+                </a:solidFill>
+                <a:latin typeface="Calibri" pitchFamily="34" charset="0"/>
+                <a:ea typeface="Calibri" pitchFamily="34" charset="-122"/>
+                <a:cs typeface="Calibri" pitchFamily="34" charset="-120"/>
+              </a:rPr>
+              <a:t>13</a:t>
+            </a:r>
+            <a:endParaRPr lang="en-US" sz="1000" dirty="0"/>
+          </a:p>
+        </p:txBody>
+      </p:sp>
+    </p:spTree>
+  </p:cSld>
+  <p:clrMapOvr>
+    <a:masterClrMapping/>
+  </p:clrMapOvr>
+</p:sld>
+</file>
+
+<file path=ppt/slides/slide14.xml><?xml version="1.0" encoding="utf-8"?>
+<p:sld xmlns:a="http://schemas.openxmlformats.org/drawingml/2006/main" xmlns:r="http://schemas.openxmlformats.org/officeDocument/2006/relationships" xmlns:p="http://schemas.openxmlformats.org/presentationml/2006/main">
+  <p:cSld name="Slide 14">
     <p:bg>
       <p:bgPr>
         <a:solidFill>
@@ -5997,7 +8459,7 @@
                 <a:ea typeface="Calibri" pitchFamily="34" charset="-122"/>
                 <a:cs typeface="Calibri" pitchFamily="34" charset="-120"/>
               </a:rPr>
-              <a:t>13</a:t>
+              <a:t>14</a:t>
             </a:r>
             <a:endParaRPr lang="en-US" sz="1000" dirty="0"/>
           </a:p>

</xml_diff>

<commit_message>
Literature check against the papers: same models to the digit, accuracies within one point
Read in full: the DSP 2022 benchmark (Zhang et al.), O'Shea et al. 2016,
Rajendran et al. 2018, Xu et al. 2020 (MCLDNN), Zhang et al. 2021
(PET-CGDNN); image tables read at 300 dpi.

- Parameter counts of all four ports equal the published ones in every
  source that lists them.
- Overall accuracy on 2016.10a (PET-CGDNN paper, Table I, one run each):
  LSTM2 60.56 vs ours 61.44, MCLDNN 62.08 vs 61.41, PET-CGDNN 60.44 vs
  60.98. Corroborated by the MCLDNN paper, Rajendran's 0-20 dB average and
  MSTFFNet's independent MCLDNN retrain; per-class 0 dB means within
  2.3 points of the MCLDNN paper's Table I.
- Not comparable: O'Shea 2016 used RadioML 2016.04 and a larger CNN.

Slide 13 of the simple deck gains a 'paper' column and says so.

Co-Authored-By: Claude Opus 5.5 <noreply@anthropic.com>
Claude-Session: https://claude.ai/code/session_01UiTC1BeuJK5BZLbarMcqjw
</commit_message>
<xml_diff>
--- a/deck/moshe_2016_simple.pptx
+++ b/deck/moshe_2016_simple.pptx
@@ -2081,7 +2081,7 @@
           <a:p>
             <a:r>
               <a:rPr lang="en-US" dirty="0"/>
-              <a:t>Is ICRNNA a good choice? I took four well-known published models, from 2016 to 2021, rewrote each one from its authors' benchmark code, and trained all of them exactly like ICRNNA: same data, same split, same three repeats. This time on all eleven types. ICRNNA is first overall, 62.2 percent, but the best four are within about one point of each other. Where ICRNNA gains is between minus 6 and minus 2 dB. Above 10 dB all four stop at about 91 percent, so that limit comes from the data, mostly WBFM and the QAM pair, not from the model. The oldest model, the 2016 CNN, stays about ten points lower up there.</a:t>
+              <a:t>Is ICRNNA a good choice? I took four well-known published models, from 2016 to 2021, rewrote each one from its authors' benchmark code, and trained all of them exactly like ICRNNA: same data, same split, same three repeats. This time on all eleven types. First, are my numbers right? Each model has exactly the number of learned parameters its paper reports, to the digit, and the accuracies the papers publish are within one point of mine, sometimes above, sometimes below. So the comparison is fair. ICRNNA is first overall, 62.2 percent, but the best four are within about one point of each other. Where ICRNNA gains is between minus 6 and minus 2 dB. Above 10 dB all four stop at about 91 percent, so that limit comes from the data, mostly WBFM and the QAM pair, not from the model. The oldest model, the 2016 CNN, stays about ten points lower up there.</a:t>
             </a:r>
             <a:endParaRPr lang="en-US" dirty="0"/>
           </a:p>
@@ -5788,13 +5788,13 @@
             <a:tbl>
               <a:tblPr/>
               <a:tblGrid>
-                <a:gridCol w="1417320"/>
-                <a:gridCol w="731520"/>
-                <a:gridCol w="1417320"/>
-                <a:gridCol w="1097280"/>
-                <a:gridCol w="1371600"/>
+                <a:gridCol w="1783080"/>
+                <a:gridCol w="1188720"/>
+                <a:gridCol w="868680"/>
+                <a:gridCol w="868680"/>
+                <a:gridCol w="1325880"/>
               </a:tblGrid>
-              <a:tr h="475488">
+              <a:tr h="438912">
                 <a:tc>
                   <a:txBody>
                     <a:bodyPr/>
@@ -5813,74 +5813,6 @@
                           <a:cs typeface="Calibri" pitchFamily="34" charset="-120"/>
                         </a:rPr>
                         <a:t>model</a:t>
-                      </a:r>
-                      <a:endParaRPr lang="en-US" sz="1300" dirty="0">
-                        <a:latin typeface="Calibri" charset="0"/>
-                        <a:ea typeface="Calibri" charset="0"/>
-                        <a:cs typeface="Calibri" charset="0"/>
-                      </a:endParaRPr>
-                    </a:p>
-                  </a:txBody>
-                  <a:tcPr marL="91440" marR="91440" marT="45720" marB="45720" anchor="ctr">
-                    <a:lnL w="6350" cap="flat" cmpd="sng" algn="ctr">
-                      <a:solidFill>
-                        <a:srgbClr val="D5DDE5"/>
-                      </a:solidFill>
-                      <a:prstDash val="solid"/>
-                      <a:round/>
-                      <a:headEnd type="none" w="med" len="med"/>
-                      <a:tailEnd type="none" w="med" len="med"/>
-                    </a:lnL>
-                    <a:lnR w="6350" cap="flat" cmpd="sng" algn="ctr">
-                      <a:solidFill>
-                        <a:srgbClr val="D5DDE5"/>
-                      </a:solidFill>
-                      <a:prstDash val="solid"/>
-                      <a:round/>
-                      <a:headEnd type="none" w="med" len="med"/>
-                      <a:tailEnd type="none" w="med" len="med"/>
-                    </a:lnR>
-                    <a:lnT w="6350" cap="flat" cmpd="sng" algn="ctr">
-                      <a:solidFill>
-                        <a:srgbClr val="D5DDE5"/>
-                      </a:solidFill>
-                      <a:prstDash val="solid"/>
-                      <a:round/>
-                      <a:headEnd type="none" w="med" len="med"/>
-                      <a:tailEnd type="none" w="med" len="med"/>
-                    </a:lnT>
-                    <a:lnB w="6350" cap="flat" cmpd="sng" algn="ctr">
-                      <a:solidFill>
-                        <a:srgbClr val="D5DDE5"/>
-                      </a:solidFill>
-                      <a:prstDash val="solid"/>
-                      <a:round/>
-                      <a:headEnd type="none" w="med" len="med"/>
-                      <a:tailEnd type="none" w="med" len="med"/>
-                    </a:lnB>
-                    <a:solidFill>
-                      <a:srgbClr val="EEF2F6"/>
-                    </a:solidFill>
-                  </a:tcPr>
-                </a:tc>
-                <a:tc>
-                  <a:txBody>
-                    <a:bodyPr/>
-                    <a:lstStyle/>
-                    <a:p>
-                      <a:pPr algn="ctr" indent="0" marL="0">
-                        <a:buNone/>
-                      </a:pPr>
-                      <a:r>
-                        <a:rPr lang="en-US" sz="1300" b="1" dirty="0">
-                          <a:solidFill>
-                            <a:srgbClr val="1E293B"/>
-                          </a:solidFill>
-                          <a:latin typeface="Calibri" pitchFamily="34" charset="0"/>
-                          <a:ea typeface="Calibri" pitchFamily="34" charset="-122"/>
-                          <a:cs typeface="Calibri" pitchFamily="34" charset="-120"/>
-                        </a:rPr>
-                        <a:t>year</a:t>
                       </a:r>
                       <a:endParaRPr lang="en-US" sz="1300" dirty="0">
                         <a:latin typeface="Calibri" charset="0"/>
@@ -6016,7 +5948,7 @@
                           <a:ea typeface="Calibri" pitchFamily="34" charset="-122"/>
                           <a:cs typeface="Calibri" pitchFamily="34" charset="-120"/>
                         </a:rPr>
-                        <a:t>overall</a:t>
+                        <a:t>paper</a:t>
                       </a:r>
                       <a:endParaRPr lang="en-US" sz="1300" dirty="0">
                         <a:latin typeface="Calibri" charset="0"/>
@@ -6084,7 +6016,7 @@
                           <a:ea typeface="Calibri" pitchFamily="34" charset="-122"/>
                           <a:cs typeface="Calibri" pitchFamily="34" charset="-120"/>
                         </a:rPr>
-                        <a:t>at 10 dB and above</a:t>
+                        <a:t>ours</a:t>
                       </a:r>
                       <a:endParaRPr lang="en-US" sz="1300" dirty="0">
                         <a:latin typeface="Calibri" charset="0"/>
@@ -6133,73 +6065,6 @@
                     <a:solidFill>
                       <a:srgbClr val="EEF2F6"/>
                     </a:solidFill>
-                  </a:tcPr>
-                </a:tc>
-              </a:tr>
-              <a:tr h="475488">
-                <a:tc>
-                  <a:txBody>
-                    <a:bodyPr/>
-                    <a:lstStyle/>
-                    <a:p>
-                      <a:pPr algn="l" indent="0" marL="0">
-                        <a:buNone/>
-                      </a:pPr>
-                      <a:r>
-                        <a:rPr lang="en-US" sz="1400" b="1" dirty="0">
-                          <a:solidFill>
-                            <a:srgbClr val="F08A24"/>
-                          </a:solidFill>
-                          <a:latin typeface="Calibri" pitchFamily="34" charset="0"/>
-                          <a:ea typeface="Calibri" pitchFamily="34" charset="-122"/>
-                          <a:cs typeface="Calibri" pitchFamily="34" charset="-120"/>
-                        </a:rPr>
-                        <a:t>ICRNNA</a:t>
-                      </a:r>
-                      <a:endParaRPr lang="en-US" sz="1400" dirty="0">
-                        <a:latin typeface="Calibri" charset="0"/>
-                        <a:ea typeface="Calibri" charset="0"/>
-                        <a:cs typeface="Calibri" charset="0"/>
-                      </a:endParaRPr>
-                    </a:p>
-                  </a:txBody>
-                  <a:tcPr marL="91440" marR="91440" marT="45720" marB="45720" anchor="ctr">
-                    <a:lnL w="6350" cap="flat" cmpd="sng" algn="ctr">
-                      <a:solidFill>
-                        <a:srgbClr val="D5DDE5"/>
-                      </a:solidFill>
-                      <a:prstDash val="solid"/>
-                      <a:round/>
-                      <a:headEnd type="none" w="med" len="med"/>
-                      <a:tailEnd type="none" w="med" len="med"/>
-                    </a:lnL>
-                    <a:lnR w="6350" cap="flat" cmpd="sng" algn="ctr">
-                      <a:solidFill>
-                        <a:srgbClr val="D5DDE5"/>
-                      </a:solidFill>
-                      <a:prstDash val="solid"/>
-                      <a:round/>
-                      <a:headEnd type="none" w="med" len="med"/>
-                      <a:tailEnd type="none" w="med" len="med"/>
-                    </a:lnR>
-                    <a:lnT w="6350" cap="flat" cmpd="sng" algn="ctr">
-                      <a:solidFill>
-                        <a:srgbClr val="D5DDE5"/>
-                      </a:solidFill>
-                      <a:prstDash val="solid"/>
-                      <a:round/>
-                      <a:headEnd type="none" w="med" len="med"/>
-                      <a:tailEnd type="none" w="med" len="med"/>
-                    </a:lnT>
-                    <a:lnB w="6350" cap="flat" cmpd="sng" algn="ctr">
-                      <a:solidFill>
-                        <a:srgbClr val="D5DDE5"/>
-                      </a:solidFill>
-                      <a:prstDash val="solid"/>
-                      <a:round/>
-                      <a:headEnd type="none" w="med" len="med"/>
-                      <a:tailEnd type="none" w="med" len="med"/>
-                    </a:lnB>
                   </a:tcPr>
                 </a:tc>
                 <a:tc>
@@ -6211,7 +6076,77 @@
                         <a:buNone/>
                       </a:pPr>
                       <a:r>
-                        <a:rPr lang="en-US" sz="1400" b="1" dirty="0">
+                        <a:rPr lang="en-US" sz="1300" b="1" dirty="0">
+                          <a:solidFill>
+                            <a:srgbClr val="1E293B"/>
+                          </a:solidFill>
+                          <a:latin typeface="Calibri" pitchFamily="34" charset="0"/>
+                          <a:ea typeface="Calibri" pitchFamily="34" charset="-122"/>
+                          <a:cs typeface="Calibri" pitchFamily="34" charset="-120"/>
+                        </a:rPr>
+                        <a:t>ours, ≥ 10 dB</a:t>
+                      </a:r>
+                      <a:endParaRPr lang="en-US" sz="1300" dirty="0">
+                        <a:latin typeface="Calibri" charset="0"/>
+                        <a:ea typeface="Calibri" charset="0"/>
+                        <a:cs typeface="Calibri" charset="0"/>
+                      </a:endParaRPr>
+                    </a:p>
+                  </a:txBody>
+                  <a:tcPr marL="91440" marR="91440" marT="45720" marB="45720" anchor="ctr">
+                    <a:lnL w="6350" cap="flat" cmpd="sng" algn="ctr">
+                      <a:solidFill>
+                        <a:srgbClr val="D5DDE5"/>
+                      </a:solidFill>
+                      <a:prstDash val="solid"/>
+                      <a:round/>
+                      <a:headEnd type="none" w="med" len="med"/>
+                      <a:tailEnd type="none" w="med" len="med"/>
+                    </a:lnL>
+                    <a:lnR w="6350" cap="flat" cmpd="sng" algn="ctr">
+                      <a:solidFill>
+                        <a:srgbClr val="D5DDE5"/>
+                      </a:solidFill>
+                      <a:prstDash val="solid"/>
+                      <a:round/>
+                      <a:headEnd type="none" w="med" len="med"/>
+                      <a:tailEnd type="none" w="med" len="med"/>
+                    </a:lnR>
+                    <a:lnT w="6350" cap="flat" cmpd="sng" algn="ctr">
+                      <a:solidFill>
+                        <a:srgbClr val="D5DDE5"/>
+                      </a:solidFill>
+                      <a:prstDash val="solid"/>
+                      <a:round/>
+                      <a:headEnd type="none" w="med" len="med"/>
+                      <a:tailEnd type="none" w="med" len="med"/>
+                    </a:lnT>
+                    <a:lnB w="6350" cap="flat" cmpd="sng" algn="ctr">
+                      <a:solidFill>
+                        <a:srgbClr val="D5DDE5"/>
+                      </a:solidFill>
+                      <a:prstDash val="solid"/>
+                      <a:round/>
+                      <a:headEnd type="none" w="med" len="med"/>
+                      <a:tailEnd type="none" w="med" len="med"/>
+                    </a:lnB>
+                    <a:solidFill>
+                      <a:srgbClr val="EEF2F6"/>
+                    </a:solidFill>
+                  </a:tcPr>
+                </a:tc>
+              </a:tr>
+              <a:tr h="438912">
+                <a:tc>
+                  <a:txBody>
+                    <a:bodyPr/>
+                    <a:lstStyle/>
+                    <a:p>
+                      <a:pPr algn="l" indent="0" marL="0">
+                        <a:buNone/>
+                      </a:pPr>
+                      <a:r>
+                        <a:rPr lang="en-US" sz="1300" b="1" dirty="0">
                           <a:solidFill>
                             <a:srgbClr val="F08A24"/>
                           </a:solidFill>
@@ -6219,9 +6154,9 @@
                           <a:ea typeface="Calibri" pitchFamily="34" charset="-122"/>
                           <a:cs typeface="Calibri" pitchFamily="34" charset="-120"/>
                         </a:rPr>
-                        <a:t>2025</a:t>
+                        <a:t>ICRNNA (2025)</a:t>
                       </a:r>
-                      <a:endParaRPr lang="en-US" sz="1400" dirty="0">
+                      <a:endParaRPr lang="en-US" sz="1300" dirty="0">
                         <a:latin typeface="Calibri" charset="0"/>
                         <a:ea typeface="Calibri" charset="0"/>
                         <a:cs typeface="Calibri" charset="0"/>
@@ -6341,6 +6276,71 @@
                         <a:buNone/>
                       </a:pPr>
                       <a:r>
+                        <a:rPr lang="en-US" sz="1400" dirty="0">
+                          <a:solidFill>
+                            <a:srgbClr val="5B6B7F"/>
+                          </a:solidFill>
+                          <a:latin typeface="Calibri" pitchFamily="34" charset="0"/>
+                          <a:ea typeface="Calibri" pitchFamily="34" charset="-122"/>
+                          <a:cs typeface="Calibri" pitchFamily="34" charset="-120"/>
+                        </a:rPr>
+                        <a:t>63.2%</a:t>
+                      </a:r>
+                      <a:endParaRPr lang="en-US" sz="1400" dirty="0">
+                        <a:latin typeface="Calibri" charset="0"/>
+                        <a:ea typeface="Calibri" charset="0"/>
+                        <a:cs typeface="Calibri" charset="0"/>
+                      </a:endParaRPr>
+                    </a:p>
+                  </a:txBody>
+                  <a:tcPr marL="91440" marR="91440" marT="45720" marB="45720" anchor="ctr">
+                    <a:lnL w="6350" cap="flat" cmpd="sng" algn="ctr">
+                      <a:solidFill>
+                        <a:srgbClr val="D5DDE5"/>
+                      </a:solidFill>
+                      <a:prstDash val="solid"/>
+                      <a:round/>
+                      <a:headEnd type="none" w="med" len="med"/>
+                      <a:tailEnd type="none" w="med" len="med"/>
+                    </a:lnL>
+                    <a:lnR w="6350" cap="flat" cmpd="sng" algn="ctr">
+                      <a:solidFill>
+                        <a:srgbClr val="D5DDE5"/>
+                      </a:solidFill>
+                      <a:prstDash val="solid"/>
+                      <a:round/>
+                      <a:headEnd type="none" w="med" len="med"/>
+                      <a:tailEnd type="none" w="med" len="med"/>
+                    </a:lnR>
+                    <a:lnT w="6350" cap="flat" cmpd="sng" algn="ctr">
+                      <a:solidFill>
+                        <a:srgbClr val="D5DDE5"/>
+                      </a:solidFill>
+                      <a:prstDash val="solid"/>
+                      <a:round/>
+                      <a:headEnd type="none" w="med" len="med"/>
+                      <a:tailEnd type="none" w="med" len="med"/>
+                    </a:lnT>
+                    <a:lnB w="6350" cap="flat" cmpd="sng" algn="ctr">
+                      <a:solidFill>
+                        <a:srgbClr val="D5DDE5"/>
+                      </a:solidFill>
+                      <a:prstDash val="solid"/>
+                      <a:round/>
+                      <a:headEnd type="none" w="med" len="med"/>
+                      <a:tailEnd type="none" w="med" len="med"/>
+                    </a:lnB>
+                  </a:tcPr>
+                </a:tc>
+                <a:tc>
+                  <a:txBody>
+                    <a:bodyPr/>
+                    <a:lstStyle/>
+                    <a:p>
+                      <a:pPr algn="ctr" indent="0" marL="0">
+                        <a:buNone/>
+                      </a:pPr>
+                      <a:r>
                         <a:rPr lang="en-US" sz="1400" b="1" dirty="0">
                           <a:solidFill>
                             <a:srgbClr val="F08A24"/>
@@ -6463,7 +6463,7 @@
                   </a:tcPr>
                 </a:tc>
               </a:tr>
-              <a:tr h="475488">
+              <a:tr h="438912">
                 <a:tc>
                   <a:txBody>
                     <a:bodyPr/>
@@ -6473,7 +6473,7 @@
                         <a:buNone/>
                       </a:pPr>
                       <a:r>
-                        <a:rPr lang="en-US" sz="1400" dirty="0">
+                        <a:rPr lang="en-US" sz="1300" dirty="0">
                           <a:solidFill>
                             <a:srgbClr val="1E293B"/>
                           </a:solidFill>
@@ -6481,74 +6481,9 @@
                           <a:ea typeface="Calibri" pitchFamily="34" charset="-122"/>
                           <a:cs typeface="Calibri" pitchFamily="34" charset="-120"/>
                         </a:rPr>
-                        <a:t>LSTM2</a:t>
+                        <a:t>LSTM2 (2018)</a:t>
                       </a:r>
-                      <a:endParaRPr lang="en-US" sz="1400" dirty="0">
-                        <a:latin typeface="Calibri" charset="0"/>
-                        <a:ea typeface="Calibri" charset="0"/>
-                        <a:cs typeface="Calibri" charset="0"/>
-                      </a:endParaRPr>
-                    </a:p>
-                  </a:txBody>
-                  <a:tcPr marL="91440" marR="91440" marT="45720" marB="45720" anchor="ctr">
-                    <a:lnL w="6350" cap="flat" cmpd="sng" algn="ctr">
-                      <a:solidFill>
-                        <a:srgbClr val="D5DDE5"/>
-                      </a:solidFill>
-                      <a:prstDash val="solid"/>
-                      <a:round/>
-                      <a:headEnd type="none" w="med" len="med"/>
-                      <a:tailEnd type="none" w="med" len="med"/>
-                    </a:lnL>
-                    <a:lnR w="6350" cap="flat" cmpd="sng" algn="ctr">
-                      <a:solidFill>
-                        <a:srgbClr val="D5DDE5"/>
-                      </a:solidFill>
-                      <a:prstDash val="solid"/>
-                      <a:round/>
-                      <a:headEnd type="none" w="med" len="med"/>
-                      <a:tailEnd type="none" w="med" len="med"/>
-                    </a:lnR>
-                    <a:lnT w="6350" cap="flat" cmpd="sng" algn="ctr">
-                      <a:solidFill>
-                        <a:srgbClr val="D5DDE5"/>
-                      </a:solidFill>
-                      <a:prstDash val="solid"/>
-                      <a:round/>
-                      <a:headEnd type="none" w="med" len="med"/>
-                      <a:tailEnd type="none" w="med" len="med"/>
-                    </a:lnT>
-                    <a:lnB w="6350" cap="flat" cmpd="sng" algn="ctr">
-                      <a:solidFill>
-                        <a:srgbClr val="D5DDE5"/>
-                      </a:solidFill>
-                      <a:prstDash val="solid"/>
-                      <a:round/>
-                      <a:headEnd type="none" w="med" len="med"/>
-                      <a:tailEnd type="none" w="med" len="med"/>
-                    </a:lnB>
-                  </a:tcPr>
-                </a:tc>
-                <a:tc>
-                  <a:txBody>
-                    <a:bodyPr/>
-                    <a:lstStyle/>
-                    <a:p>
-                      <a:pPr algn="ctr" indent="0" marL="0">
-                        <a:buNone/>
-                      </a:pPr>
-                      <a:r>
-                        <a:rPr lang="en-US" sz="1400" dirty="0">
-                          <a:solidFill>
-                            <a:srgbClr val="1E293B"/>
-                          </a:solidFill>
-                          <a:latin typeface="Calibri" pitchFamily="34" charset="0"/>
-                          <a:ea typeface="Calibri" pitchFamily="34" charset="-122"/>
-                          <a:cs typeface="Calibri" pitchFamily="34" charset="-120"/>
-                        </a:rPr>
-                        <a:t>2018</a:t>
-                      </a:r>
-                      <a:endParaRPr lang="en-US" sz="1400" dirty="0">
+                      <a:endParaRPr lang="en-US" sz="1300" dirty="0">
                         <a:latin typeface="Calibri" charset="0"/>
                         <a:ea typeface="Calibri" charset="0"/>
                         <a:cs typeface="Calibri" charset="0"/>
@@ -6670,6 +6605,71 @@
                       <a:r>
                         <a:rPr lang="en-US" sz="1400" dirty="0">
                           <a:solidFill>
+                            <a:srgbClr val="5B6B7F"/>
+                          </a:solidFill>
+                          <a:latin typeface="Calibri" pitchFamily="34" charset="0"/>
+                          <a:ea typeface="Calibri" pitchFamily="34" charset="-122"/>
+                          <a:cs typeface="Calibri" pitchFamily="34" charset="-120"/>
+                        </a:rPr>
+                        <a:t>60.6%</a:t>
+                      </a:r>
+                      <a:endParaRPr lang="en-US" sz="1400" dirty="0">
+                        <a:latin typeface="Calibri" charset="0"/>
+                        <a:ea typeface="Calibri" charset="0"/>
+                        <a:cs typeface="Calibri" charset="0"/>
+                      </a:endParaRPr>
+                    </a:p>
+                  </a:txBody>
+                  <a:tcPr marL="91440" marR="91440" marT="45720" marB="45720" anchor="ctr">
+                    <a:lnL w="6350" cap="flat" cmpd="sng" algn="ctr">
+                      <a:solidFill>
+                        <a:srgbClr val="D5DDE5"/>
+                      </a:solidFill>
+                      <a:prstDash val="solid"/>
+                      <a:round/>
+                      <a:headEnd type="none" w="med" len="med"/>
+                      <a:tailEnd type="none" w="med" len="med"/>
+                    </a:lnL>
+                    <a:lnR w="6350" cap="flat" cmpd="sng" algn="ctr">
+                      <a:solidFill>
+                        <a:srgbClr val="D5DDE5"/>
+                      </a:solidFill>
+                      <a:prstDash val="solid"/>
+                      <a:round/>
+                      <a:headEnd type="none" w="med" len="med"/>
+                      <a:tailEnd type="none" w="med" len="med"/>
+                    </a:lnR>
+                    <a:lnT w="6350" cap="flat" cmpd="sng" algn="ctr">
+                      <a:solidFill>
+                        <a:srgbClr val="D5DDE5"/>
+                      </a:solidFill>
+                      <a:prstDash val="solid"/>
+                      <a:round/>
+                      <a:headEnd type="none" w="med" len="med"/>
+                      <a:tailEnd type="none" w="med" len="med"/>
+                    </a:lnT>
+                    <a:lnB w="6350" cap="flat" cmpd="sng" algn="ctr">
+                      <a:solidFill>
+                        <a:srgbClr val="D5DDE5"/>
+                      </a:solidFill>
+                      <a:prstDash val="solid"/>
+                      <a:round/>
+                      <a:headEnd type="none" w="med" len="med"/>
+                      <a:tailEnd type="none" w="med" len="med"/>
+                    </a:lnB>
+                  </a:tcPr>
+                </a:tc>
+                <a:tc>
+                  <a:txBody>
+                    <a:bodyPr/>
+                    <a:lstStyle/>
+                    <a:p>
+                      <a:pPr algn="ctr" indent="0" marL="0">
+                        <a:buNone/>
+                      </a:pPr>
+                      <a:r>
+                        <a:rPr lang="en-US" sz="1400" dirty="0">
+                          <a:solidFill>
                             <a:srgbClr val="1E293B"/>
                           </a:solidFill>
                           <a:latin typeface="Calibri" pitchFamily="34" charset="0"/>
@@ -6790,7 +6790,7 @@
                   </a:tcPr>
                 </a:tc>
               </a:tr>
-              <a:tr h="475488">
+              <a:tr h="438912">
                 <a:tc>
                   <a:txBody>
                     <a:bodyPr/>
@@ -6800,7 +6800,7 @@
                         <a:buNone/>
                       </a:pPr>
                       <a:r>
-                        <a:rPr lang="en-US" sz="1400" dirty="0">
+                        <a:rPr lang="en-US" sz="1300" dirty="0">
                           <a:solidFill>
                             <a:srgbClr val="1E293B"/>
                           </a:solidFill>
@@ -6808,74 +6808,9 @@
                           <a:ea typeface="Calibri" pitchFamily="34" charset="-122"/>
                           <a:cs typeface="Calibri" pitchFamily="34" charset="-120"/>
                         </a:rPr>
-                        <a:t>MCLDNN</a:t>
+                        <a:t>MCLDNN (2020)</a:t>
                       </a:r>
-                      <a:endParaRPr lang="en-US" sz="1400" dirty="0">
-                        <a:latin typeface="Calibri" charset="0"/>
-                        <a:ea typeface="Calibri" charset="0"/>
-                        <a:cs typeface="Calibri" charset="0"/>
-                      </a:endParaRPr>
-                    </a:p>
-                  </a:txBody>
-                  <a:tcPr marL="91440" marR="91440" marT="45720" marB="45720" anchor="ctr">
-                    <a:lnL w="6350" cap="flat" cmpd="sng" algn="ctr">
-                      <a:solidFill>
-                        <a:srgbClr val="D5DDE5"/>
-                      </a:solidFill>
-                      <a:prstDash val="solid"/>
-                      <a:round/>
-                      <a:headEnd type="none" w="med" len="med"/>
-                      <a:tailEnd type="none" w="med" len="med"/>
-                    </a:lnL>
-                    <a:lnR w="6350" cap="flat" cmpd="sng" algn="ctr">
-                      <a:solidFill>
-                        <a:srgbClr val="D5DDE5"/>
-                      </a:solidFill>
-                      <a:prstDash val="solid"/>
-                      <a:round/>
-                      <a:headEnd type="none" w="med" len="med"/>
-                      <a:tailEnd type="none" w="med" len="med"/>
-                    </a:lnR>
-                    <a:lnT w="6350" cap="flat" cmpd="sng" algn="ctr">
-                      <a:solidFill>
-                        <a:srgbClr val="D5DDE5"/>
-                      </a:solidFill>
-                      <a:prstDash val="solid"/>
-                      <a:round/>
-                      <a:headEnd type="none" w="med" len="med"/>
-                      <a:tailEnd type="none" w="med" len="med"/>
-                    </a:lnT>
-                    <a:lnB w="6350" cap="flat" cmpd="sng" algn="ctr">
-                      <a:solidFill>
-                        <a:srgbClr val="D5DDE5"/>
-                      </a:solidFill>
-                      <a:prstDash val="solid"/>
-                      <a:round/>
-                      <a:headEnd type="none" w="med" len="med"/>
-                      <a:tailEnd type="none" w="med" len="med"/>
-                    </a:lnB>
-                  </a:tcPr>
-                </a:tc>
-                <a:tc>
-                  <a:txBody>
-                    <a:bodyPr/>
-                    <a:lstStyle/>
-                    <a:p>
-                      <a:pPr algn="ctr" indent="0" marL="0">
-                        <a:buNone/>
-                      </a:pPr>
-                      <a:r>
-                        <a:rPr lang="en-US" sz="1400" dirty="0">
-                          <a:solidFill>
-                            <a:srgbClr val="1E293B"/>
-                          </a:solidFill>
-                          <a:latin typeface="Calibri" pitchFamily="34" charset="0"/>
-                          <a:ea typeface="Calibri" pitchFamily="34" charset="-122"/>
-                          <a:cs typeface="Calibri" pitchFamily="34" charset="-120"/>
-                        </a:rPr>
-                        <a:t>2020</a:t>
-                      </a:r>
-                      <a:endParaRPr lang="en-US" sz="1400" dirty="0">
+                      <a:endParaRPr lang="en-US" sz="1300" dirty="0">
                         <a:latin typeface="Calibri" charset="0"/>
                         <a:ea typeface="Calibri" charset="0"/>
                         <a:cs typeface="Calibri" charset="0"/>
@@ -6997,6 +6932,71 @@
                       <a:r>
                         <a:rPr lang="en-US" sz="1400" dirty="0">
                           <a:solidFill>
+                            <a:srgbClr val="5B6B7F"/>
+                          </a:solidFill>
+                          <a:latin typeface="Calibri" pitchFamily="34" charset="0"/>
+                          <a:ea typeface="Calibri" pitchFamily="34" charset="-122"/>
+                          <a:cs typeface="Calibri" pitchFamily="34" charset="-120"/>
+                        </a:rPr>
+                        <a:t>62.1%</a:t>
+                      </a:r>
+                      <a:endParaRPr lang="en-US" sz="1400" dirty="0">
+                        <a:latin typeface="Calibri" charset="0"/>
+                        <a:ea typeface="Calibri" charset="0"/>
+                        <a:cs typeface="Calibri" charset="0"/>
+                      </a:endParaRPr>
+                    </a:p>
+                  </a:txBody>
+                  <a:tcPr marL="91440" marR="91440" marT="45720" marB="45720" anchor="ctr">
+                    <a:lnL w="6350" cap="flat" cmpd="sng" algn="ctr">
+                      <a:solidFill>
+                        <a:srgbClr val="D5DDE5"/>
+                      </a:solidFill>
+                      <a:prstDash val="solid"/>
+                      <a:round/>
+                      <a:headEnd type="none" w="med" len="med"/>
+                      <a:tailEnd type="none" w="med" len="med"/>
+                    </a:lnL>
+                    <a:lnR w="6350" cap="flat" cmpd="sng" algn="ctr">
+                      <a:solidFill>
+                        <a:srgbClr val="D5DDE5"/>
+                      </a:solidFill>
+                      <a:prstDash val="solid"/>
+                      <a:round/>
+                      <a:headEnd type="none" w="med" len="med"/>
+                      <a:tailEnd type="none" w="med" len="med"/>
+                    </a:lnR>
+                    <a:lnT w="6350" cap="flat" cmpd="sng" algn="ctr">
+                      <a:solidFill>
+                        <a:srgbClr val="D5DDE5"/>
+                      </a:solidFill>
+                      <a:prstDash val="solid"/>
+                      <a:round/>
+                      <a:headEnd type="none" w="med" len="med"/>
+                      <a:tailEnd type="none" w="med" len="med"/>
+                    </a:lnT>
+                    <a:lnB w="6350" cap="flat" cmpd="sng" algn="ctr">
+                      <a:solidFill>
+                        <a:srgbClr val="D5DDE5"/>
+                      </a:solidFill>
+                      <a:prstDash val="solid"/>
+                      <a:round/>
+                      <a:headEnd type="none" w="med" len="med"/>
+                      <a:tailEnd type="none" w="med" len="med"/>
+                    </a:lnB>
+                  </a:tcPr>
+                </a:tc>
+                <a:tc>
+                  <a:txBody>
+                    <a:bodyPr/>
+                    <a:lstStyle/>
+                    <a:p>
+                      <a:pPr algn="ctr" indent="0" marL="0">
+                        <a:buNone/>
+                      </a:pPr>
+                      <a:r>
+                        <a:rPr lang="en-US" sz="1400" dirty="0">
+                          <a:solidFill>
                             <a:srgbClr val="1E293B"/>
                           </a:solidFill>
                           <a:latin typeface="Calibri" pitchFamily="34" charset="0"/>
@@ -7117,7 +7117,7 @@
                   </a:tcPr>
                 </a:tc>
               </a:tr>
-              <a:tr h="475488">
+              <a:tr h="438912">
                 <a:tc>
                   <a:txBody>
                     <a:bodyPr/>
@@ -7127,7 +7127,7 @@
                         <a:buNone/>
                       </a:pPr>
                       <a:r>
-                        <a:rPr lang="en-US" sz="1400" dirty="0">
+                        <a:rPr lang="en-US" sz="1300" dirty="0">
                           <a:solidFill>
                             <a:srgbClr val="1E293B"/>
                           </a:solidFill>
@@ -7135,74 +7135,9 @@
                           <a:ea typeface="Calibri" pitchFamily="34" charset="-122"/>
                           <a:cs typeface="Calibri" pitchFamily="34" charset="-120"/>
                         </a:rPr>
-                        <a:t>PET-CGDNN</a:t>
+                        <a:t>PET-CGDNN (2021)</a:t>
                       </a:r>
-                      <a:endParaRPr lang="en-US" sz="1400" dirty="0">
-                        <a:latin typeface="Calibri" charset="0"/>
-                        <a:ea typeface="Calibri" charset="0"/>
-                        <a:cs typeface="Calibri" charset="0"/>
-                      </a:endParaRPr>
-                    </a:p>
-                  </a:txBody>
-                  <a:tcPr marL="91440" marR="91440" marT="45720" marB="45720" anchor="ctr">
-                    <a:lnL w="6350" cap="flat" cmpd="sng" algn="ctr">
-                      <a:solidFill>
-                        <a:srgbClr val="D5DDE5"/>
-                      </a:solidFill>
-                      <a:prstDash val="solid"/>
-                      <a:round/>
-                      <a:headEnd type="none" w="med" len="med"/>
-                      <a:tailEnd type="none" w="med" len="med"/>
-                    </a:lnL>
-                    <a:lnR w="6350" cap="flat" cmpd="sng" algn="ctr">
-                      <a:solidFill>
-                        <a:srgbClr val="D5DDE5"/>
-                      </a:solidFill>
-                      <a:prstDash val="solid"/>
-                      <a:round/>
-                      <a:headEnd type="none" w="med" len="med"/>
-                      <a:tailEnd type="none" w="med" len="med"/>
-                    </a:lnR>
-                    <a:lnT w="6350" cap="flat" cmpd="sng" algn="ctr">
-                      <a:solidFill>
-                        <a:srgbClr val="D5DDE5"/>
-                      </a:solidFill>
-                      <a:prstDash val="solid"/>
-                      <a:round/>
-                      <a:headEnd type="none" w="med" len="med"/>
-                      <a:tailEnd type="none" w="med" len="med"/>
-                    </a:lnT>
-                    <a:lnB w="6350" cap="flat" cmpd="sng" algn="ctr">
-                      <a:solidFill>
-                        <a:srgbClr val="D5DDE5"/>
-                      </a:solidFill>
-                      <a:prstDash val="solid"/>
-                      <a:round/>
-                      <a:headEnd type="none" w="med" len="med"/>
-                      <a:tailEnd type="none" w="med" len="med"/>
-                    </a:lnB>
-                  </a:tcPr>
-                </a:tc>
-                <a:tc>
-                  <a:txBody>
-                    <a:bodyPr/>
-                    <a:lstStyle/>
-                    <a:p>
-                      <a:pPr algn="ctr" indent="0" marL="0">
-                        <a:buNone/>
-                      </a:pPr>
-                      <a:r>
-                        <a:rPr lang="en-US" sz="1400" dirty="0">
-                          <a:solidFill>
-                            <a:srgbClr val="1E293B"/>
-                          </a:solidFill>
-                          <a:latin typeface="Calibri" pitchFamily="34" charset="0"/>
-                          <a:ea typeface="Calibri" pitchFamily="34" charset="-122"/>
-                          <a:cs typeface="Calibri" pitchFamily="34" charset="-120"/>
-                        </a:rPr>
-                        <a:t>2021</a:t>
-                      </a:r>
-                      <a:endParaRPr lang="en-US" sz="1400" dirty="0">
+                      <a:endParaRPr lang="en-US" sz="1300" dirty="0">
                         <a:latin typeface="Calibri" charset="0"/>
                         <a:ea typeface="Calibri" charset="0"/>
                         <a:cs typeface="Calibri" charset="0"/>
@@ -7324,6 +7259,71 @@
                       <a:r>
                         <a:rPr lang="en-US" sz="1400" dirty="0">
                           <a:solidFill>
+                            <a:srgbClr val="5B6B7F"/>
+                          </a:solidFill>
+                          <a:latin typeface="Calibri" pitchFamily="34" charset="0"/>
+                          <a:ea typeface="Calibri" pitchFamily="34" charset="-122"/>
+                          <a:cs typeface="Calibri" pitchFamily="34" charset="-120"/>
+                        </a:rPr>
+                        <a:t>60.4%</a:t>
+                      </a:r>
+                      <a:endParaRPr lang="en-US" sz="1400" dirty="0">
+                        <a:latin typeface="Calibri" charset="0"/>
+                        <a:ea typeface="Calibri" charset="0"/>
+                        <a:cs typeface="Calibri" charset="0"/>
+                      </a:endParaRPr>
+                    </a:p>
+                  </a:txBody>
+                  <a:tcPr marL="91440" marR="91440" marT="45720" marB="45720" anchor="ctr">
+                    <a:lnL w="6350" cap="flat" cmpd="sng" algn="ctr">
+                      <a:solidFill>
+                        <a:srgbClr val="D5DDE5"/>
+                      </a:solidFill>
+                      <a:prstDash val="solid"/>
+                      <a:round/>
+                      <a:headEnd type="none" w="med" len="med"/>
+                      <a:tailEnd type="none" w="med" len="med"/>
+                    </a:lnL>
+                    <a:lnR w="6350" cap="flat" cmpd="sng" algn="ctr">
+                      <a:solidFill>
+                        <a:srgbClr val="D5DDE5"/>
+                      </a:solidFill>
+                      <a:prstDash val="solid"/>
+                      <a:round/>
+                      <a:headEnd type="none" w="med" len="med"/>
+                      <a:tailEnd type="none" w="med" len="med"/>
+                    </a:lnR>
+                    <a:lnT w="6350" cap="flat" cmpd="sng" algn="ctr">
+                      <a:solidFill>
+                        <a:srgbClr val="D5DDE5"/>
+                      </a:solidFill>
+                      <a:prstDash val="solid"/>
+                      <a:round/>
+                      <a:headEnd type="none" w="med" len="med"/>
+                      <a:tailEnd type="none" w="med" len="med"/>
+                    </a:lnT>
+                    <a:lnB w="6350" cap="flat" cmpd="sng" algn="ctr">
+                      <a:solidFill>
+                        <a:srgbClr val="D5DDE5"/>
+                      </a:solidFill>
+                      <a:prstDash val="solid"/>
+                      <a:round/>
+                      <a:headEnd type="none" w="med" len="med"/>
+                      <a:tailEnd type="none" w="med" len="med"/>
+                    </a:lnB>
+                  </a:tcPr>
+                </a:tc>
+                <a:tc>
+                  <a:txBody>
+                    <a:bodyPr/>
+                    <a:lstStyle/>
+                    <a:p>
+                      <a:pPr algn="ctr" indent="0" marL="0">
+                        <a:buNone/>
+                      </a:pPr>
+                      <a:r>
+                        <a:rPr lang="en-US" sz="1400" dirty="0">
+                          <a:solidFill>
                             <a:srgbClr val="1E293B"/>
                           </a:solidFill>
                           <a:latin typeface="Calibri" pitchFamily="34" charset="0"/>
@@ -7444,7 +7444,7 @@
                   </a:tcPr>
                 </a:tc>
               </a:tr>
-              <a:tr h="475488">
+              <a:tr h="438912">
                 <a:tc>
                   <a:txBody>
                     <a:bodyPr/>
@@ -7454,7 +7454,7 @@
                         <a:buNone/>
                       </a:pPr>
                       <a:r>
-                        <a:rPr lang="en-US" sz="1400" dirty="0">
+                        <a:rPr lang="en-US" sz="1300" dirty="0">
                           <a:solidFill>
                             <a:srgbClr val="1E293B"/>
                           </a:solidFill>
@@ -7462,74 +7462,9 @@
                           <a:ea typeface="Calibri" pitchFamily="34" charset="-122"/>
                           <a:cs typeface="Calibri" pitchFamily="34" charset="-120"/>
                         </a:rPr>
-                        <a:t>VT-CNN2</a:t>
+                        <a:t>VT-CNN2 (2016)</a:t>
                       </a:r>
-                      <a:endParaRPr lang="en-US" sz="1400" dirty="0">
-                        <a:latin typeface="Calibri" charset="0"/>
-                        <a:ea typeface="Calibri" charset="0"/>
-                        <a:cs typeface="Calibri" charset="0"/>
-                      </a:endParaRPr>
-                    </a:p>
-                  </a:txBody>
-                  <a:tcPr marL="91440" marR="91440" marT="45720" marB="45720" anchor="ctr">
-                    <a:lnL w="6350" cap="flat" cmpd="sng" algn="ctr">
-                      <a:solidFill>
-                        <a:srgbClr val="D5DDE5"/>
-                      </a:solidFill>
-                      <a:prstDash val="solid"/>
-                      <a:round/>
-                      <a:headEnd type="none" w="med" len="med"/>
-                      <a:tailEnd type="none" w="med" len="med"/>
-                    </a:lnL>
-                    <a:lnR w="6350" cap="flat" cmpd="sng" algn="ctr">
-                      <a:solidFill>
-                        <a:srgbClr val="D5DDE5"/>
-                      </a:solidFill>
-                      <a:prstDash val="solid"/>
-                      <a:round/>
-                      <a:headEnd type="none" w="med" len="med"/>
-                      <a:tailEnd type="none" w="med" len="med"/>
-                    </a:lnR>
-                    <a:lnT w="6350" cap="flat" cmpd="sng" algn="ctr">
-                      <a:solidFill>
-                        <a:srgbClr val="D5DDE5"/>
-                      </a:solidFill>
-                      <a:prstDash val="solid"/>
-                      <a:round/>
-                      <a:headEnd type="none" w="med" len="med"/>
-                      <a:tailEnd type="none" w="med" len="med"/>
-                    </a:lnT>
-                    <a:lnB w="6350" cap="flat" cmpd="sng" algn="ctr">
-                      <a:solidFill>
-                        <a:srgbClr val="D5DDE5"/>
-                      </a:solidFill>
-                      <a:prstDash val="solid"/>
-                      <a:round/>
-                      <a:headEnd type="none" w="med" len="med"/>
-                      <a:tailEnd type="none" w="med" len="med"/>
-                    </a:lnB>
-                  </a:tcPr>
-                </a:tc>
-                <a:tc>
-                  <a:txBody>
-                    <a:bodyPr/>
-                    <a:lstStyle/>
-                    <a:p>
-                      <a:pPr algn="ctr" indent="0" marL="0">
-                        <a:buNone/>
-                      </a:pPr>
-                      <a:r>
-                        <a:rPr lang="en-US" sz="1400" dirty="0">
-                          <a:solidFill>
-                            <a:srgbClr val="1E293B"/>
-                          </a:solidFill>
-                          <a:latin typeface="Calibri" pitchFamily="34" charset="0"/>
-                          <a:ea typeface="Calibri" pitchFamily="34" charset="-122"/>
-                          <a:cs typeface="Calibri" pitchFamily="34" charset="-120"/>
-                        </a:rPr>
-                        <a:t>2016</a:t>
-                      </a:r>
-                      <a:endParaRPr lang="en-US" sz="1400" dirty="0">
+                      <a:endParaRPr lang="en-US" sz="1300" dirty="0">
                         <a:latin typeface="Calibri" charset="0"/>
                         <a:ea typeface="Calibri" charset="0"/>
                         <a:cs typeface="Calibri" charset="0"/>
@@ -7651,6 +7586,71 @@
                       <a:r>
                         <a:rPr lang="en-US" sz="1400" dirty="0">
                           <a:solidFill>
+                            <a:srgbClr val="5B6B7F"/>
+                          </a:solidFill>
+                          <a:latin typeface="Calibri" pitchFamily="34" charset="0"/>
+                          <a:ea typeface="Calibri" pitchFamily="34" charset="-122"/>
+                          <a:cs typeface="Calibri" pitchFamily="34" charset="-120"/>
+                        </a:rPr>
+                        <a:t>—</a:t>
+                      </a:r>
+                      <a:endParaRPr lang="en-US" sz="1400" dirty="0">
+                        <a:latin typeface="Calibri" charset="0"/>
+                        <a:ea typeface="Calibri" charset="0"/>
+                        <a:cs typeface="Calibri" charset="0"/>
+                      </a:endParaRPr>
+                    </a:p>
+                  </a:txBody>
+                  <a:tcPr marL="91440" marR="91440" marT="45720" marB="45720" anchor="ctr">
+                    <a:lnL w="6350" cap="flat" cmpd="sng" algn="ctr">
+                      <a:solidFill>
+                        <a:srgbClr val="D5DDE5"/>
+                      </a:solidFill>
+                      <a:prstDash val="solid"/>
+                      <a:round/>
+                      <a:headEnd type="none" w="med" len="med"/>
+                      <a:tailEnd type="none" w="med" len="med"/>
+                    </a:lnL>
+                    <a:lnR w="6350" cap="flat" cmpd="sng" algn="ctr">
+                      <a:solidFill>
+                        <a:srgbClr val="D5DDE5"/>
+                      </a:solidFill>
+                      <a:prstDash val="solid"/>
+                      <a:round/>
+                      <a:headEnd type="none" w="med" len="med"/>
+                      <a:tailEnd type="none" w="med" len="med"/>
+                    </a:lnR>
+                    <a:lnT w="6350" cap="flat" cmpd="sng" algn="ctr">
+                      <a:solidFill>
+                        <a:srgbClr val="D5DDE5"/>
+                      </a:solidFill>
+                      <a:prstDash val="solid"/>
+                      <a:round/>
+                      <a:headEnd type="none" w="med" len="med"/>
+                      <a:tailEnd type="none" w="med" len="med"/>
+                    </a:lnT>
+                    <a:lnB w="6350" cap="flat" cmpd="sng" algn="ctr">
+                      <a:solidFill>
+                        <a:srgbClr val="D5DDE5"/>
+                      </a:solidFill>
+                      <a:prstDash val="solid"/>
+                      <a:round/>
+                      <a:headEnd type="none" w="med" len="med"/>
+                      <a:tailEnd type="none" w="med" len="med"/>
+                    </a:lnB>
+                  </a:tcPr>
+                </a:tc>
+                <a:tc>
+                  <a:txBody>
+                    <a:bodyPr/>
+                    <a:lstStyle/>
+                    <a:p>
+                      <a:pPr algn="ctr" indent="0" marL="0">
+                        <a:buNone/>
+                      </a:pPr>
+                      <a:r>
+                        <a:rPr lang="en-US" sz="1400" dirty="0">
+                          <a:solidFill>
                             <a:srgbClr val="1E293B"/>
                           </a:solidFill>
                           <a:latin typeface="Calibri" pitchFamily="34" charset="0"/>
@@ -7784,7 +7784,7 @@
         <p:spPr>
           <a:xfrm>
             <a:off x="548640" y="4800600"/>
-            <a:ext cx="6035040" cy="457200"/>
+            <a:ext cx="6035040" cy="731520"/>
           </a:xfrm>
           <a:prstGeom prst="rect">
             <a:avLst/>
@@ -7800,7 +7800,7 @@
               <a:buNone/>
             </a:pPr>
             <a:r>
-              <a:rPr lang="en-US" sz="1100" i="1" dirty="0">
+              <a:rPr lang="en-US" sz="1050" i="1" dirty="0">
                 <a:solidFill>
                   <a:srgbClr val="5B6B7F"/>
                 </a:solidFill>
@@ -7808,9 +7808,9 @@
                 <a:ea typeface="Calibri" pitchFamily="34" charset="-122"/>
                 <a:cs typeface="Calibri" pitchFamily="34" charset="-120"/>
               </a:rPr>
-              <a:t>Models from Zhang et al., Digital Signal Processing 2022 (their code, rewritten line by line).</a:t>
-            </a:r>
-            <a:endParaRPr lang="en-US" sz="1100" dirty="0"/>
+              <a:t>“Paper”: overall accuracy as published — ICRNNA from its own paper (we measure our colleague's version of it); the others from Zhang et al. 2021, one run each. Same number of learned parameters as published, to the digit.</a:t>
+            </a:r>
+            <a:endParaRPr lang="en-US" sz="1050" dirty="0"/>
           </a:p>
         </p:txBody>
       </p:sp>
@@ -7871,7 +7871,7 @@
                 <a:ea typeface="Calibri" pitchFamily="34" charset="-122"/>
                 <a:cs typeface="Calibri" pitchFamily="34" charset="-120"/>
               </a:rPr>
-              <a:t>ICRNNA is first overall, but the best four are within 1.2 points.</a:t>
+              <a:t>Our numbers match the papers within 1 point. ICRNNA is first, the best four within 1.2 points.</a:t>
             </a:r>
             <a:pPr indent="0" marL="0">
               <a:buNone/>

</xml_diff>

<commit_message>
Simpler spoken script for the simple 2016 deck
Short sentences, plain words, one message per slide, about 12 minutes
in total. Same text in the slide notes, TALK_simple.md and the study
page; the Turkish explanations and the questions are unchanged.

Co-Authored-By: Claude Opus 5.5 <noreply@anthropic.com>
Claude-Session: https://claude.ai/code/session_01UiTC1BeuJK5BZLbarMcqjw
</commit_message>
<xml_diff>
--- a/deck/moshe_2016_simple.pptx
+++ b/deck/moshe_2016_simple.pptx
@@ -1729,7 +1729,7 @@
           <a:p>
             <a:r>
               <a:rPr lang="en-US" dirty="0"/>
-              <a:t>Today I will show what our detector does, step by step, on the four signals you asked about: BPSK, QPSK, QAM16 and QAM64. On the right is one QAM16 frame: sixteen symbols, and you can watch them spread out as the noise grows. Everything is on the RML2016.10a dataset, the one the group uses.</a:t>
+              <a:t>Today I want to open up our detector and show you what it does, step by step. I'll use the four signals you asked about: BPSK, QPSK, QAM16 and QAM64. The picture on the right is one QAM16 frame. Watch the sixteen points spread out as the noise grows. That picture is really today's whole talk: how many symbols we have, and how much noise is on them.</a:t>
             </a:r>
             <a:endParaRPr lang="en-US" dirty="0"/>
           </a:p>
@@ -1817,7 +1817,7 @@
           <a:p>
             <a:r>
               <a:rPr lang="en-US" dirty="0"/>
-              <a:t>Then, as you asked, turn the noise up. These bars are the number of wrong answers out of 8,400 at each label. From 10 dB down to 2 dB it stays at about 450 to 490: the same box every time. Below 0 dB it starts to break, and QPSK is the first to slip, into the QAMs. So the mistakes we have at 10 dB are not caused by noise.</a:t>
+              <a:t>Then, as you asked, I turned the noise up, one level at a time. The bars are the mistakes out of 8,400. From 10 dB down to 2 dB: about 450 to 490. Eight dB more noise, and nothing changes. Same mistakes. Below 0 dB it breaks, and the first to go is QPSK: it starts to look like a QAM. So the mistakes at 10 dB are not caused by noise. Then what causes them?</a:t>
             </a:r>
             <a:endParaRPr lang="en-US" dirty="0"/>
           </a:p>
@@ -1905,7 +1905,7 @@
           <a:p>
             <a:r>
               <a:rPr lang="en-US" dirty="0"/>
-              <a:t>So what does cause them? Frame length. I cut every frame to 64 samples, which is 8 symbols, and to 32 samples, 4 symbols, and trained again. The curves fall at about the same noise level, but they flatten at different heights: 5.7 percent wrong with 16 symbols, 15.5 with 8, 25.2 with 4. On the right: with fewer symbols you see fewer points of the grid, and QAM16 and QAM64 become harder to tell apart. More signal does not fix this; more symbols does.</a:t>
+              <a:t>My guess was the frame length. So I cut every frame in half, to eight symbols, and in half again, to four, and trained the same model again. Look at the right side of the chart, where the noise is low. Every curve goes flat. With sixteen symbols, 5.7 percent wrong. With eight, 15.5. With four, 25. Almost all of that is the QAM pair. With four symbols, QAM16 against QAM64 is a coin flip. The picture on the right shows why: fewer symbols, fewer grid points, and the two QAMs look the same. So noise decides where the curve drops. The number of symbols decides how low it can go. More signal won't fix it. More symbols will.</a:t>
             </a:r>
             <a:endParaRPr lang="en-US" dirty="0"/>
           </a:p>
@@ -1993,7 +1993,7 @@
           <a:p>
             <a:r>
               <a:rPr lang="en-US" dirty="0"/>
-              <a:t>One thing we found. At minus 20 dB there is no signal at all, but the detector still has to name one of the four. QPSK recall there is 52 percent, which looks like it recognises QPSK. It does not: of all the frames it calls QPSK, only 25 percent are QPSK, which is a guess. It sends almost everything, 98.8 percent, to BPSK or QPSK, and which of the two changes from one training run to the next. That is why every chart now shows precision next to recall, and how many decisions each point is based on.</a:t>
+              <a:t>One thing we found along the way. At minus 20 dB there is basically no signal. But the detector can't say "I don't know", so it has to pick one. QPSK recall there is 52 percent. That looks like it still recognises QPSK. It doesn't. Precision is 25 percent: of everything it calls QPSK, only a quarter really is. That's a guess. What really happens: with nothing to go on, it says BPSK or QPSK almost every time, and which of the two changes from run to run. The lesson: recall alone can fool you. So every chart now shows precision next to recall, and how many decisions are behind each point.</a:t>
             </a:r>
             <a:endParaRPr lang="en-US" dirty="0"/>
           </a:p>
@@ -2081,7 +2081,7 @@
           <a:p>
             <a:r>
               <a:rPr lang="en-US" dirty="0"/>
-              <a:t>Is ICRNNA a good choice? I took four well-known published models, from 2016 to 2021, rewrote each one from its authors' benchmark code, and trained all of them exactly like ICRNNA: same data, same split, same three repeats. This time on all eleven types. First, are my numbers right? Each model has exactly the number of learned parameters its paper reports, to the digit, and the accuracies the papers publish are within one point of mine, sometimes above, sometimes below. So the comparison is fair. ICRNNA is first overall, 62.2 percent, but the best four are within about one point of each other. Where ICRNNA gains is between minus 6 and minus 2 dB. Above 10 dB all four stop at about 91 percent, so that limit comes from the data, mostly WBFM and the QAM pair, not from the model. The oldest model, the 2016 CNN, stays about ten points lower up there.</a:t>
+              <a:t>Is ICRNNA a good choice? I took four well-known published models and trained them exactly like ICRNNA: same data, same split, same repeats. This time all eleven types, because that's what the papers report. First, can you trust my numbers? Each model has exactly the same number of parameters as in its paper. And my accuracies are within one point of the published ones. So it's a fair comparison. The result: ICRNNA is first, at 62.2 percent, but the top four are within about one point. And above 10 dB they all stop at around 91 percent. When four different designs hit the same ceiling, the limit is in the data, not in the model. Only the oldest one, from 2016, is clearly behind.</a:t>
             </a:r>
             <a:endParaRPr lang="en-US" dirty="0"/>
           </a:p>
@@ -2169,7 +2169,7 @@
           <a:p>
             <a:r>
               <a:rPr lang="en-US" dirty="0"/>
-              <a:t>To sum up. BPSK and QPSK are essentially solved; the mistakes are QAM16 against QAM64. Those mistakes come from having only 16 symbols, not from noise: with 8 or 4 symbols they grow 2.7 and 4.3 times. And 10 dB in this dataset is a setting, not a measurement. Next, I want to switch off the carrier offset, the fading and the echoes one at a time and see which one the QAM mistakes belong to. Thank you.</a:t>
+              <a:t>So, three things. One: BPSK and QPSK are solved. The mistakes are QAM16 against QAM64. Two: those mistakes come from having only sixteen symbols, not from noise. With eight symbols there are almost three times as many, with four more than four times. Three: "10 dB" here is a setting, not a measurement, and it's different for each signal. Next, I'll switch off the frequency offset, the fading and the echoes one at a time, and see which one the QAM mistakes follow. Thank you.</a:t>
             </a:r>
             <a:endParaRPr lang="en-US" dirty="0"/>
           </a:p>
@@ -2257,7 +2257,7 @@
           <a:p>
             <a:r>
               <a:rPr lang="en-US" dirty="0"/>
-              <a:t>First, in one minute, what this is about. AMC means automatic modulation classification. A receiver picks up a radio signal that nobody described to it, and has to say how it was modulated: is it BPSK, QPSK, QAM, FM? It matters for watching the spectrum, for finding interference, and for radios that adapt to what they hear. What I work on has three parts. First, a detector that does this, trained on a standard dataset that everyone in the field uses, RML2016.10a, which is simulated. Second, opening that detector up: what exactly it does, what the noise in the data is, and where it fails. That is today. Third, the bigger question of my project: why detectors like this lose accuracy when the signal comes from a different transmitter, and what fixes it. Today I stay with the first two, on four signals: BPSK, QPSK, QAM16 and QAM64.</a:t>
+              <a:t>Quickly, what this is about. A receiver picks up a signal, and nobody told it what kind of signal it is. AMC, automatic modulation classification, answers one question: how was this signal modulated? You need that to watch the spectrum, to find interference, and for radios that adapt to what they hear. My work has three steps. One: a detector that does this, trained on a standard simulated dataset. Two: open it up. What does it do, what is the noise really, and where does it fail? Three, the real question of the project: why do these detectors get worse on a signal from a different transmitter? Today is steps one and two.</a:t>
             </a:r>
             <a:endParaRPr lang="en-US" dirty="0"/>
           </a:p>
@@ -2345,7 +2345,7 @@
           <a:p>
             <a:r>
               <a:rPr lang="en-US" dirty="0"/>
-              <a:t>The data. I use RML2016.10a, made by DeepSig in a radio simulator in 2016; it is the dataset most papers in this field report on. It has 11 modulation types, 8 digital and 3 analog. Each type is given at 20 noise levels, from minus 20 to plus 18 dB, with 1,000 frames at each level: 220,000 frames in total. Every frame is 128 samples, which is 16 symbols. Today I use four of the eleven, in orange: BPSK and QPSK, which only change the phase, and QAM16 and QAM64, which also change the amplitude.</a:t>
+              <a:t>The data is RML2016.10a. DeepSig made it in a simulator in 2016, and most papers in this field use it. Eleven signal types. Twenty noise levels, from minus twenty to plus eighteen dB. A thousand frames of each type at each level. That's two hundred and twenty thousand frames. One frame is 128 samples, and that is only sixteen symbols. Please remember that number. Today I use the four in orange. BPSK and QPSK only change the phase. QAM16 and QAM64 change the phase and the amplitude.</a:t>
             </a:r>
             <a:endParaRPr lang="en-US" dirty="0"/>
           </a:p>
@@ -2433,7 +2433,7 @@
           <a:p>
             <a:r>
               <a:rPr lang="en-US" dirty="0"/>
-              <a:t>The detector is given 128 samples of a radio signal and has to say which of the four it is. It works in three steps. First it looks at short pieces of the frame, about one and a half symbols each, so the frame becomes 32 pieces. Second, it reads those pieces in order, forwards and backwards, so that each piece knows about the whole frame. Third, it takes a weighted average of the 32 pieces and turns it into four scores; the largest score is the answer. In total it has 785 thousand numbers that it learns, and 84 percent of them are in the second step. Once trained, nothing in it is random: the same frame always gets the same answer.</a:t>
+              <a:t>The detector gets 128 samples and has to say which of the four it is. It does that in three steps. First, it looks at short pieces, about one and a half symbols each. The frame becomes thirty-two pieces. Second, it reads those pieces in order, forwards and backwards, a bit like reading a sentence. After that, every piece knows about the whole frame. This part is an LSTM, and it holds most of the model, 84 percent. Third, it decides. It weighs the pieces, averages them, and gives four scores. The biggest score wins. Two things to keep in mind. Once trained, it is not random: same frame, same answer. And it can never say "I don't know". That will matter later.</a:t>
             </a:r>
             <a:endParaRPr lang="en-US" dirty="0"/>
           </a:p>
@@ -2521,7 +2521,7 @@
           <a:p>
             <a:r>
               <a:rPr lang="en-US" dirty="0"/>
-              <a:t>Where it came from. The design is from a 2025 paper; the model is called ICRNNA. A colleague re-implemented that paper, and our code is copied from their version, which differs from the paper in five small places. To check that the paper's number is real, I rebuilt the model from the paper alone and trained it until it stopped improving: 63.21 percent against the paper's 63.24. And to be clear about the tools: the code, the plots and these slides were written with Claude Code, an AI coding assistant. Every number comes from running that code on a GPU, and what to test was my choice. [Say here who the colleague is and how the work before September was done.]</a:t>
+              <a:t>Where did it come from? The design is from a 2025 paper; the model is called ICRNNA. A colleague coded it up, and our code comes from theirs. It's close to the paper, with five small differences. I wanted to check the paper's number, so I built the model again from the paper alone. Trained long enough, it gets 63.21 percent. The paper says 63.24. So the number is real. And to be open about my tools: the code, the plots and these slides were written with Claude Code, an AI assistant. The numbers come from actually running that code. What to test was my decision. [Say here who the colleague is and how the work before September was done.]</a:t>
             </a:r>
             <a:endParaRPr lang="en-US" dirty="0"/>
           </a:p>
@@ -2609,7 +2609,7 @@
           <a:p>
             <a:r>
               <a:rPr lang="en-US" dirty="0"/>
-              <a:t>This is the whole experiment on one slide. Input: the RML2016.10a dataset, made by DeepSig in a simulator: four kinds of signal, twenty noise levels, a thousand frames each. One frame is 128 samples, which is 16 symbols. The detector learns on 70 percent of the frames, uses 15 percent to decide when to stop learning, and is tested on the last 15 percent, which it never saw. I repeated this 14 times with a different split each time. Output: at 10 dB and above it is right 94.2 percent of the time, over 42,000 test decisions. BPSK and QPSK are right 99.6 percent of the time. At minus 20 dB it is at 25 percent, which with four choices is a guess.</a:t>
+              <a:t>Here is the whole experiment on one slide. In: four signal types, twenty noise levels, a thousand frames each. The detector learns on 70 percent of the frames. It uses 15 percent to decide when to stop. And it is tested on the last 15 percent, which it has never seen. I did this fourteen times with different splits, so it isn't luck. Out: at 10 dB and above, it is right 94 percent of the time, over 42,000 decisions. BPSK and QPSK are almost perfect. At minus 20 dB it is right 25 percent of the time, and with four choices that is just a guess. Now let's open each part: the input, the noise, then the answer.</a:t>
             </a:r>
             <a:endParaRPr lang="en-US" dirty="0"/>
           </a:p>
@@ -2697,7 +2697,7 @@
           <a:p>
             <a:r>
               <a:rPr lang="en-US" dirty="0"/>
-              <a:t>Step one: what the detector actually sees. This is one QAM16 frame, drawn without noise. The orange line is the in-phase part, the blue line the quadrature part. Every 8 samples there is one symbol, the dots, and each dot sits on minus 3, minus 1, 1 or 3. That pattern is what makes it QAM16. On the right are the 16 symbols of one frame for each kind, drawn on all the points that kind can use. QAM64 has 64 points, but a frame only has 16 symbols, so it can show at most 16 of them. A QAM64 frame can look like QAM16 even with no noise at all. Keep that in mind.</a:t>
+              <a:t>First, the input. This is one QAM16 frame, drawn without noise. Orange is the I part, blue is the Q part. Every eight samples there is a symbol, the dots. Each dot sits on one of four levels. Four levels times four levels: sixteen points. That's QAM16. On the right are the sixteen symbols of one frame, drawn on all the points each type can use. BPSK has two points, so sixteen symbols cover it many times. But QAM64 has sixty-four points, and we only have sixteen symbols. We never see the whole grid. So a QAM64 frame can look like QAM16 even with no noise at all. Keep that in mind.</a:t>
             </a:r>
             <a:endParaRPr lang="en-US" dirty="0"/>
           </a:p>
@@ -2785,7 +2785,7 @@
           <a:p>
             <a:r>
               <a:rPr lang="en-US" dirty="0"/>
-              <a:t>Step two: the noise. You asked what 10 dB is the ratio of. The dataset was made by DeepSig in a simulator. In their code, the label sets exactly one number: the noise amplitude, 10 to the minus label over 10. Besides noise, every frame also gets a carrier offset, a clock offset, fading and echoes, at every noise level, even the best one. I did not want to rely on their code, so I measured the noise in the file itself: the signal sits in the middle of the spectrum, and outside it there is only noise. Two findings. One dB of label is about 1.9 dB of real change, so the label moves twice as fast as its name. And at the same label, QAM64 frames have about 15 dB more signal than BPSK and QPSK frames. So 10 dB here is a setting, not a measurement, and it means a different noise level for each kind of signal.</a:t>
+              <a:t>Second, the noise. You asked what "10 dB" actually is. The short answer: it's a setting in their code, not a measurement. In the code, the label sets one thing, the noise amplitude. Not the power. So one dB of label really moves the noise by about two dB. And noise is not the only thing added. Every frame also gets a frequency offset, a clock offset, fading and echoes. Even the cleanest frames. I didn't want to just trust the code, so I measured the noise in the file. The signal sits in the middle of the band; outside it there is only noise. Two findings. One dB of label is 1.9 dB of real change. And at the same label, QAM64 has about 15 dB more signal than BPSK and QPSK. So "10 dB" means a different noise level for each signal.</a:t>
             </a:r>
             <a:endParaRPr lang="en-US" dirty="0"/>
           </a:p>
@@ -2873,7 +2873,7 @@
           <a:p>
             <a:r>
               <a:rPr lang="en-US" dirty="0"/>
-              <a:t>The answer at one noise level, 10 dB. 8,400 test frames. Each row is what was sent, each column what the detector said. Recall is a row: of the frames that were QPSK, how many it called QPSK. Precision is a column: of the frames it called QPSK, how many really were. BPSK and QPSK are at 99.6 percent. 448 frames out of 8,400 are wrong, and 395 of those are QAM16 and QAM64 mixed up.</a:t>
+              <a:t>Now the answer, at one noise level: 10 dB. Rows are what was sent, columns are what the detector said. The diagonal is correct. Two words I'll use. Recall is a row: of the real QPSK frames, how many did it get? Precision is a column: when it says QPSK, how often is it right? BPSK and QPSK: 99.6 percent. Solved. 448 mistakes out of 8,400. And 395 of them are just QAM16 and QAM64 confused with each other. So at 10 dB there is really one problem left: QAM16 against QAM64.</a:t>
             </a:r>
             <a:endParaRPr lang="en-US" dirty="0"/>
           </a:p>

</xml_diff>

<commit_message>
Halve the spoken script of the simple deck (about 6 minutes)
Co-Authored-By: Claude Opus 5.5 <noreply@anthropic.com>
Claude-Session: https://claude.ai/code/session_01UiTC1BeuJK5BZLbarMcqjw
</commit_message>
<xml_diff>
--- a/deck/moshe_2016_simple.pptx
+++ b/deck/moshe_2016_simple.pptx
@@ -1729,7 +1729,7 @@
           <a:p>
             <a:r>
               <a:rPr lang="en-US" dirty="0"/>
-              <a:t>Today I want to open up our detector and show you what it does, step by step. I'll use the four signals you asked about: BPSK, QPSK, QAM16 and QAM64. The picture on the right is one QAM16 frame. Watch the sixteen points spread out as the noise grows. That picture is really today's whole talk: how many symbols we have, and how much noise is on them.</a:t>
+              <a:t>Today I'll open up our detector, step by step, on the four signals you asked about: BPSK, QPSK, QAM16 and QAM64. The picture is one QAM16 frame: sixteen points, spreading out as the noise grows. That's the whole talk: how many symbols, and how much noise.</a:t>
             </a:r>
             <a:endParaRPr lang="en-US" dirty="0"/>
           </a:p>
@@ -1817,7 +1817,7 @@
           <a:p>
             <a:r>
               <a:rPr lang="en-US" dirty="0"/>
-              <a:t>Then, as you asked, I turned the noise up, one level at a time. The bars are the mistakes out of 8,400. From 10 dB down to 2 dB: about 450 to 490. Eight dB more noise, and nothing changes. Same mistakes. Below 0 dB it breaks, and the first to go is QPSK: it starts to look like a QAM. So the mistakes at 10 dB are not caused by noise. Then what causes them?</a:t>
+              <a:t>Then I turned the noise up. From 10 down to 2 dB the mistakes stay around 450 to 490. Nothing changes. It only breaks below 0 dB. So the mistakes at 10 dB are not noise. Then what are they?</a:t>
             </a:r>
             <a:endParaRPr lang="en-US" dirty="0"/>
           </a:p>
@@ -1905,7 +1905,7 @@
           <a:p>
             <a:r>
               <a:rPr lang="en-US" dirty="0"/>
-              <a:t>My guess was the frame length. So I cut every frame in half, to eight symbols, and in half again, to four, and trained the same model again. Look at the right side of the chart, where the noise is low. Every curve goes flat. With sixteen symbols, 5.7 percent wrong. With eight, 15.5. With four, 25. Almost all of that is the QAM pair. With four symbols, QAM16 against QAM64 is a coin flip. The picture on the right shows why: fewer symbols, fewer grid points, and the two QAMs look the same. So noise decides where the curve drops. The number of symbols decides how low it can go. More signal won't fix it. More symbols will.</a:t>
+              <a:t>Frame length. I cut the frames to eight symbols, then four, and trained again. At low noise every curve goes flat: 5.7 percent wrong with sixteen symbols, 15.5 with eight, 25 with four. Almost all of it is the QAM pair. Noise decides where the curve drops. Symbols decide how low it can go.</a:t>
             </a:r>
             <a:endParaRPr lang="en-US" dirty="0"/>
           </a:p>
@@ -1993,7 +1993,7 @@
           <a:p>
             <a:r>
               <a:rPr lang="en-US" dirty="0"/>
-              <a:t>One thing we found along the way. At minus 20 dB there is basically no signal. But the detector can't say "I don't know", so it has to pick one. QPSK recall there is 52 percent. That looks like it still recognises QPSK. It doesn't. Precision is 25 percent: of everything it calls QPSK, only a quarter really is. That's a guess. What really happens: with nothing to go on, it says BPSK or QPSK almost every time, and which of the two changes from run to run. The lesson: recall alone can fool you. So every chart now shows precision next to recall, and how many decisions are behind each point.</a:t>
+              <a:t>At minus 20 dB there's no signal, but it still has to pick one. QPSK recall is 52 percent, which looks good. But precision is 25 percent: a guess. It just says BPSK or QPSK almost every time. So now every chart shows precision next to recall.</a:t>
             </a:r>
             <a:endParaRPr lang="en-US" dirty="0"/>
           </a:p>
@@ -2081,7 +2081,7 @@
           <a:p>
             <a:r>
               <a:rPr lang="en-US" dirty="0"/>
-              <a:t>Is ICRNNA a good choice? I took four well-known published models and trained them exactly like ICRNNA: same data, same split, same repeats. This time all eleven types, because that's what the papers report. First, can you trust my numbers? Each model has exactly the same number of parameters as in its paper. And my accuracies are within one point of the published ones. So it's a fair comparison. The result: ICRNNA is first, at 62.2 percent, but the top four are within about one point. And above 10 dB they all stop at around 91 percent. When four different designs hit the same ceiling, the limit is in the data, not in the model. Only the oldest one, from 2016, is clearly behind.</a:t>
+              <a:t>Is ICRNNA a good choice? I trained four published models the same way, on all eleven types. They have the same parameter counts as in their papers, and accuracy within one point of what the papers publish. ICRNNA is first, but the top four are within one point, and above 10 dB they all stop near 91 percent. That limit is in the data, not the model.</a:t>
             </a:r>
             <a:endParaRPr lang="en-US" dirty="0"/>
           </a:p>
@@ -2169,7 +2169,7 @@
           <a:p>
             <a:r>
               <a:rPr lang="en-US" dirty="0"/>
-              <a:t>So, three things. One: BPSK and QPSK are solved. The mistakes are QAM16 against QAM64. Two: those mistakes come from having only sixteen symbols, not from noise. With eight symbols there are almost three times as many, with four more than four times. Three: "10 dB" here is a setting, not a measurement, and it's different for each signal. Next, I'll switch off the frequency offset, the fading and the echoes one at a time, and see which one the QAM mistakes follow. Thank you.</a:t>
+              <a:t>Three things. BPSK and QPSK are solved; the mistakes are QAM16 against QAM64. Those come from having only sixteen symbols, not from noise. And "10 dB" is a setting, not a measurement. Next: switch off the channel effects one at a time, and see which one the QAM mistakes follow. Thank you.</a:t>
             </a:r>
             <a:endParaRPr lang="en-US" dirty="0"/>
           </a:p>
@@ -2257,7 +2257,7 @@
           <a:p>
             <a:r>
               <a:rPr lang="en-US" dirty="0"/>
-              <a:t>Quickly, what this is about. A receiver picks up a signal, and nobody told it what kind of signal it is. AMC, automatic modulation classification, answers one question: how was this signal modulated? You need that to watch the spectrum, to find interference, and for radios that adapt to what they hear. My work has three steps. One: a detector that does this, trained on a standard simulated dataset. Two: open it up. What does it do, what is the noise really, and where does it fail? Three, the real question of the project: why do these detectors get worse on a signal from a different transmitter? Today is steps one and two.</a:t>
+              <a:t>AMC means automatic modulation classification. A receiver gets a signal and has to say how it was modulated. You need that to watch the spectrum, to find interference, and for radios that adapt. My work has three steps: build a detector, open it up, then ask why it gets worse on a different transmitter. Today is the first two.</a:t>
             </a:r>
             <a:endParaRPr lang="en-US" dirty="0"/>
           </a:p>
@@ -2345,7 +2345,7 @@
           <a:p>
             <a:r>
               <a:rPr lang="en-US" dirty="0"/>
-              <a:t>The data is RML2016.10a. DeepSig made it in a simulator in 2016, and most papers in this field use it. Eleven signal types. Twenty noise levels, from minus twenty to plus eighteen dB. A thousand frames of each type at each level. That's two hundred and twenty thousand frames. One frame is 128 samples, and that is only sixteen symbols. Please remember that number. Today I use the four in orange. BPSK and QPSK only change the phase. QAM16 and QAM64 change the phase and the amplitude.</a:t>
+              <a:t>The data is RML2016.10a, from DeepSig. It's simulated, and most papers use it. Eleven signal types, twenty noise levels, a thousand frames each. One frame is 128 samples: only sixteen symbols. Remember that. Today, the four in orange. BPSK and QPSK change only the phase; the QAMs also change the amplitude.</a:t>
             </a:r>
             <a:endParaRPr lang="en-US" dirty="0"/>
           </a:p>
@@ -2433,7 +2433,7 @@
           <a:p>
             <a:r>
               <a:rPr lang="en-US" dirty="0"/>
-              <a:t>The detector gets 128 samples and has to say which of the four it is. It does that in three steps. First, it looks at short pieces, about one and a half symbols each. The frame becomes thirty-two pieces. Second, it reads those pieces in order, forwards and backwards, a bit like reading a sentence. After that, every piece knows about the whole frame. This part is an LSTM, and it holds most of the model, 84 percent. Third, it decides. It weighs the pieces, averages them, and gives four scores. The biggest score wins. Two things to keep in mind. Once trained, it is not random: same frame, same answer. And it can never say "I don't know". That will matter later.</a:t>
+              <a:t>The detector works in three steps. It looks at short pieces of the frame. It reads them in order, forwards and backwards; that's where most of the model is. Then it gives four scores, and the biggest wins. Once trained: same frame, same answer. And it can never say "I don't know".</a:t>
             </a:r>
             <a:endParaRPr lang="en-US" dirty="0"/>
           </a:p>
@@ -2521,7 +2521,7 @@
           <a:p>
             <a:r>
               <a:rPr lang="en-US" dirty="0"/>
-              <a:t>Where did it come from? The design is from a 2025 paper; the model is called ICRNNA. A colleague coded it up, and our code comes from theirs. It's close to the paper, with five small differences. I wanted to check the paper's number, so I built the model again from the paper alone. Trained long enough, it gets 63.21 percent. The paper says 63.24. So the number is real. And to be open about my tools: the code, the plots and these slides were written with Claude Code, an AI assistant. The numbers come from actually running that code. What to test was my decision. [Say here who the colleague is and how the work before September was done.]</a:t>
+              <a:t>The design is from a 2025 paper; the model is called ICRNNA. Our code comes from a colleague's version, with five small differences. I rebuilt it from the paper alone: 63.21 percent, against the paper's 63.24. So the number is real. The code and slides were written with Claude Code, an AI assistant. The numbers come from running that code, and what to test was my choice. [Say here who the colleague is and how the work before September was done.]</a:t>
             </a:r>
             <a:endParaRPr lang="en-US" dirty="0"/>
           </a:p>
@@ -2609,7 +2609,7 @@
           <a:p>
             <a:r>
               <a:rPr lang="en-US" dirty="0"/>
-              <a:t>Here is the whole experiment on one slide. In: four signal types, twenty noise levels, a thousand frames each. The detector learns on 70 percent of the frames. It uses 15 percent to decide when to stop. And it is tested on the last 15 percent, which it has never seen. I did this fourteen times with different splits, so it isn't luck. Out: at 10 dB and above, it is right 94 percent of the time, over 42,000 decisions. BPSK and QPSK are almost perfect. At minus 20 dB it is right 25 percent of the time, and with four choices that is just a guess. Now let's open each part: the input, the noise, then the answer.</a:t>
+              <a:t>The whole experiment: the detector learns on 70 percent of the frames, uses 15 to decide when to stop, and is tested on 15 it never saw. Fourteen times, with different splits. Result: 94 percent right at 10 dB and above. BPSK and QPSK almost perfect. At minus 20 dB, 25 percent: a guess.</a:t>
             </a:r>
             <a:endParaRPr lang="en-US" dirty="0"/>
           </a:p>
@@ -2697,7 +2697,7 @@
           <a:p>
             <a:r>
               <a:rPr lang="en-US" dirty="0"/>
-              <a:t>First, the input. This is one QAM16 frame, drawn without noise. Orange is the I part, blue is the Q part. Every eight samples there is a symbol, the dots. Each dot sits on one of four levels. Four levels times four levels: sixteen points. That's QAM16. On the right are the sixteen symbols of one frame, drawn on all the points each type can use. BPSK has two points, so sixteen symbols cover it many times. But QAM64 has sixty-four points, and we only have sixteen symbols. We never see the whole grid. So a QAM64 frame can look like QAM16 even with no noise at all. Keep that in mind.</a:t>
+              <a:t>This is one QAM16 frame, without noise. A symbol every eight samples, each on one of four levels. Four times four: sixteen points. Now the key point. QAM64 has sixty-four points, but a frame has only sixteen symbols. So a QAM64 frame can look like QAM16 even with no noise.</a:t>
             </a:r>
             <a:endParaRPr lang="en-US" dirty="0"/>
           </a:p>
@@ -2785,7 +2785,7 @@
           <a:p>
             <a:r>
               <a:rPr lang="en-US" dirty="0"/>
-              <a:t>Second, the noise. You asked what "10 dB" actually is. The short answer: it's a setting in their code, not a measurement. In the code, the label sets one thing, the noise amplitude. Not the power. So one dB of label really moves the noise by about two dB. And noise is not the only thing added. Every frame also gets a frequency offset, a clock offset, fading and echoes. Even the cleanest frames. I didn't want to just trust the code, so I measured the noise in the file. The signal sits in the middle of the band; outside it there is only noise. Two findings. One dB of label is 1.9 dB of real change. And at the same label, QAM64 has about 15 dB more signal than BPSK and QPSK. So "10 dB" means a different noise level for each signal.</a:t>
+              <a:t>You asked what "10 dB" is. It's a setting in their code, not a measurement. It sets the noise amplitude, not the power, so one dB of label is really about two. I measured it in the file: 1.9. And at the same label, QAM64 has about 15 dB more signal than BPSK and QPSK. So "10 dB" is a different noise level for each signal.</a:t>
             </a:r>
             <a:endParaRPr lang="en-US" dirty="0"/>
           </a:p>
@@ -2873,7 +2873,7 @@
           <a:p>
             <a:r>
               <a:rPr lang="en-US" dirty="0"/>
-              <a:t>Now the answer, at one noise level: 10 dB. Rows are what was sent, columns are what the detector said. The diagonal is correct. Two words I'll use. Recall is a row: of the real QPSK frames, how many did it get? Precision is a column: when it says QPSK, how often is it right? BPSK and QPSK: 99.6 percent. Solved. 448 mistakes out of 8,400. And 395 of them are just QAM16 and QAM64 confused with each other. So at 10 dB there is really one problem left: QAM16 against QAM64.</a:t>
+              <a:t>At 10 dB: rows are what was sent, columns what it said. Recall is a row, precision is a column. BPSK and QPSK: 99.6 percent. 448 mistakes out of 8,400, and 395 of them are QAM16 and QAM64 mixed up. One problem left.</a:t>
             </a:r>
             <a:endParaRPr lang="en-US" dirty="0"/>
           </a:p>

</xml_diff>